<commit_message>
Add right-side footer (ClosureCopilot / Mayuresh Piske / (c) 2026 Microsoft) to slides; rebuild demo video with footer, voiceover unchanged
Co-authored-by: Copilot <223556219+Copilot@users.noreply.github.com>
</commit_message>
<xml_diff>
--- a/docs/ClosureCopilot.pptx
+++ b/docs/ClosureCopilot.pptx
@@ -4,17 +4,20 @@
   <p:sldMasterIdLst>
     <p:sldMasterId id="2147483648" r:id="rId1"/>
   </p:sldMasterIdLst>
+  <p:notesMasterIdLst>
+    <p:notesMasterId r:id="rId10"/>
+  </p:notesMasterIdLst>
   <p:sldIdLst>
-    <p:sldId id="256" r:id="rId7"/>
-    <p:sldId id="257" r:id="rId8"/>
-    <p:sldId id="258" r:id="rId9"/>
-    <p:sldId id="259" r:id="rId10"/>
-    <p:sldId id="260" r:id="rId11"/>
-    <p:sldId id="261" r:id="rId12"/>
-    <p:sldId id="262" r:id="rId13"/>
-    <p:sldId id="263" r:id="rId14"/>
+    <p:sldId id="256" r:id="rId2"/>
+    <p:sldId id="257" r:id="rId3"/>
+    <p:sldId id="258" r:id="rId4"/>
+    <p:sldId id="259" r:id="rId5"/>
+    <p:sldId id="260" r:id="rId6"/>
+    <p:sldId id="261" r:id="rId7"/>
+    <p:sldId id="262" r:id="rId8"/>
+    <p:sldId id="263" r:id="rId9"/>
   </p:sldIdLst>
-  <p:sldSz cx="12191695" cy="6858000" type="screen4x3"/>
+  <p:sldSz cx="12192000" cy="6858000"/>
   <p:notesSz cx="6858000" cy="9144000"/>
   <p:defaultTextStyle>
     <a:defPPr>
@@ -111,7 +114,587 @@
       </a:defRPr>
     </a:lvl9pPr>
   </p:defaultTextStyle>
+  <p:extLst>
+    <p:ext uri="{EFAFB233-063F-42B5-8137-9DF3F51BA10A}">
+      <p15:sldGuideLst xmlns:p15="http://schemas.microsoft.com/office/powerpoint/2012/main">
+        <p15:guide id="1" orient="horz" pos="2160">
+          <p15:clr>
+            <a:srgbClr val="A4A3A4"/>
+          </p15:clr>
+        </p15:guide>
+        <p15:guide id="2" pos="2880">
+          <p15:clr>
+            <a:srgbClr val="A4A3A4"/>
+          </p15:clr>
+        </p15:guide>
+      </p15:sldGuideLst>
+    </p:ext>
+  </p:extLst>
 </p:presentation>
+</file>
+
+<file path=ppt/revisionInfo.xml><?xml version="1.0" encoding="utf-8"?>
+<p1510:revInfo xmlns:a="http://schemas.openxmlformats.org/drawingml/2006/main" xmlns:r="http://schemas.openxmlformats.org/officeDocument/2006/relationships" xmlns:p1510="http://schemas.microsoft.com/office/powerpoint/2015/10/main">
+  <p1510:revLst>
+    <p1510:client id="{116BD6CD-ED46-48F3-A6FF-3F84F00B2497}" v="10" dt="2026-09-05T15:26:55.215"/>
+  </p1510:revLst>
+</p1510:revInfo>
+</file>
+
+<file path=ppt/changesInfos/changesInfo1.xml><?xml version="1.0" encoding="utf-8"?>
+<pc:chgInfo xmlns:a="http://schemas.openxmlformats.org/drawingml/2006/main" xmlns:r="http://schemas.openxmlformats.org/officeDocument/2006/relationships" xmlns:ac="http://schemas.microsoft.com/office/drawing/2013/main/command" xmlns:pc="http://schemas.microsoft.com/office/powerpoint/2013/main/command">
+  <pc:docChgLst>
+    <pc:chgData name="Mayuresh Piske" userId="aeb3d3e9-2c13-446e-8fc0-83f22db42824" providerId="ADAL" clId="{76688486-0801-4EB8-8479-3CA377FA07D4}"/>
+    <pc:docChg chg="undo custSel modSld">
+      <pc:chgData name="Mayuresh Piske" userId="aeb3d3e9-2c13-446e-8fc0-83f22db42824" providerId="ADAL" clId="{76688486-0801-4EB8-8479-3CA377FA07D4}" dt="2026-09-05T15:36:38.970" v="104" actId="20577"/>
+      <pc:docMkLst>
+        <pc:docMk/>
+      </pc:docMkLst>
+      <pc:sldChg chg="addSp delSp modSp mod">
+        <pc:chgData name="Mayuresh Piske" userId="aeb3d3e9-2c13-446e-8fc0-83f22db42824" providerId="ADAL" clId="{76688486-0801-4EB8-8479-3CA377FA07D4}" dt="2026-09-05T15:35:46.493" v="95" actId="478"/>
+        <pc:sldMkLst>
+          <pc:docMk/>
+          <pc:sldMk cId="0" sldId="256"/>
+        </pc:sldMkLst>
+        <pc:spChg chg="mod">
+          <ac:chgData name="Mayuresh Piske" userId="aeb3d3e9-2c13-446e-8fc0-83f22db42824" providerId="ADAL" clId="{76688486-0801-4EB8-8479-3CA377FA07D4}" dt="2026-09-05T15:26:34.418" v="39" actId="1076"/>
+          <ac:spMkLst>
+            <pc:docMk/>
+            <pc:sldMk cId="0" sldId="256"/>
+            <ac:spMk id="3" creationId="{00000000-0000-0000-0000-000000000000}"/>
+          </ac:spMkLst>
+        </pc:spChg>
+        <pc:spChg chg="add mod">
+          <ac:chgData name="Mayuresh Piske" userId="aeb3d3e9-2c13-446e-8fc0-83f22db42824" providerId="ADAL" clId="{76688486-0801-4EB8-8479-3CA377FA07D4}" dt="2026-09-05T15:19:12.708" v="4" actId="571"/>
+          <ac:spMkLst>
+            <pc:docMk/>
+            <pc:sldMk cId="0" sldId="256"/>
+            <ac:spMk id="8" creationId="{7160E950-381A-9493-E97E-A5C157321C4D}"/>
+          </ac:spMkLst>
+        </pc:spChg>
+        <pc:spChg chg="add mod">
+          <ac:chgData name="Mayuresh Piske" userId="aeb3d3e9-2c13-446e-8fc0-83f22db42824" providerId="ADAL" clId="{76688486-0801-4EB8-8479-3CA377FA07D4}" dt="2026-09-05T15:19:21.693" v="7" actId="571"/>
+          <ac:spMkLst>
+            <pc:docMk/>
+            <pc:sldMk cId="0" sldId="256"/>
+            <ac:spMk id="9" creationId="{F9C852E8-C7BC-811C-B1EF-9314B6D6C9AA}"/>
+          </ac:spMkLst>
+        </pc:spChg>
+        <pc:spChg chg="add mod">
+          <ac:chgData name="Mayuresh Piske" userId="aeb3d3e9-2c13-446e-8fc0-83f22db42824" providerId="ADAL" clId="{76688486-0801-4EB8-8479-3CA377FA07D4}" dt="2026-09-05T15:19:43.651" v="25" actId="404"/>
+          <ac:spMkLst>
+            <pc:docMk/>
+            <pc:sldMk cId="0" sldId="256"/>
+            <ac:spMk id="11" creationId="{B25F93AE-AE4B-0369-7B8A-DF9D4A6D992F}"/>
+          </ac:spMkLst>
+        </pc:spChg>
+        <pc:spChg chg="del mod">
+          <ac:chgData name="Mayuresh Piske" userId="aeb3d3e9-2c13-446e-8fc0-83f22db42824" providerId="ADAL" clId="{76688486-0801-4EB8-8479-3CA377FA07D4}" dt="2026-09-05T15:35:46.493" v="95" actId="478"/>
+          <ac:spMkLst>
+            <pc:docMk/>
+            <pc:sldMk cId="0" sldId="256"/>
+            <ac:spMk id="12" creationId="{56D8762E-D1DB-7AEA-C625-87FE1BCBAC7A}"/>
+          </ac:spMkLst>
+        </pc:spChg>
+      </pc:sldChg>
+      <pc:sldChg chg="delSp modSp mod">
+        <pc:chgData name="Mayuresh Piske" userId="aeb3d3e9-2c13-446e-8fc0-83f22db42824" providerId="ADAL" clId="{76688486-0801-4EB8-8479-3CA377FA07D4}" dt="2026-09-05T15:28:49.532" v="76" actId="1076"/>
+        <pc:sldMkLst>
+          <pc:docMk/>
+          <pc:sldMk cId="0" sldId="257"/>
+        </pc:sldMkLst>
+        <pc:spChg chg="del mod">
+          <ac:chgData name="Mayuresh Piske" userId="aeb3d3e9-2c13-446e-8fc0-83f22db42824" providerId="ADAL" clId="{76688486-0801-4EB8-8479-3CA377FA07D4}" dt="2026-09-05T15:26:23.488" v="36" actId="478"/>
+          <ac:spMkLst>
+            <pc:docMk/>
+            <pc:sldMk cId="0" sldId="257"/>
+            <ac:spMk id="2" creationId="{00000000-0000-0000-0000-000000000000}"/>
+          </ac:spMkLst>
+        </pc:spChg>
+        <pc:spChg chg="mod">
+          <ac:chgData name="Mayuresh Piske" userId="aeb3d3e9-2c13-446e-8fc0-83f22db42824" providerId="ADAL" clId="{76688486-0801-4EB8-8479-3CA377FA07D4}" dt="2026-09-05T15:28:49.532" v="76" actId="1076"/>
+          <ac:spMkLst>
+            <pc:docMk/>
+            <pc:sldMk cId="0" sldId="257"/>
+            <ac:spMk id="13" creationId="{2CD06639-3C8E-33C0-FE69-B7ADA560992A}"/>
+          </ac:spMkLst>
+        </pc:spChg>
+      </pc:sldChg>
+      <pc:sldChg chg="modSp mod">
+        <pc:chgData name="Mayuresh Piske" userId="aeb3d3e9-2c13-446e-8fc0-83f22db42824" providerId="ADAL" clId="{76688486-0801-4EB8-8479-3CA377FA07D4}" dt="2026-09-05T15:36:38.970" v="104" actId="20577"/>
+        <pc:sldMkLst>
+          <pc:docMk/>
+          <pc:sldMk cId="0" sldId="258"/>
+        </pc:sldMkLst>
+        <pc:spChg chg="mod">
+          <ac:chgData name="Mayuresh Piske" userId="aeb3d3e9-2c13-446e-8fc0-83f22db42824" providerId="ADAL" clId="{76688486-0801-4EB8-8479-3CA377FA07D4}" dt="2026-09-05T15:36:38.970" v="104" actId="20577"/>
+          <ac:spMkLst>
+            <pc:docMk/>
+            <pc:sldMk cId="0" sldId="258"/>
+            <ac:spMk id="4" creationId="{00000000-0000-0000-0000-000000000000}"/>
+          </ac:spMkLst>
+        </pc:spChg>
+        <pc:spChg chg="mod">
+          <ac:chgData name="Mayuresh Piske" userId="aeb3d3e9-2c13-446e-8fc0-83f22db42824" providerId="ADAL" clId="{76688486-0801-4EB8-8479-3CA377FA07D4}" dt="2026-09-05T15:36:10.470" v="97" actId="14100"/>
+          <ac:spMkLst>
+            <pc:docMk/>
+            <pc:sldMk cId="0" sldId="258"/>
+            <ac:spMk id="7" creationId="{70C64B5F-0A6D-53D4-7F8E-684E630ACE64}"/>
+          </ac:spMkLst>
+        </pc:spChg>
+        <pc:picChg chg="mod">
+          <ac:chgData name="Mayuresh Piske" userId="aeb3d3e9-2c13-446e-8fc0-83f22db42824" providerId="ADAL" clId="{76688486-0801-4EB8-8479-3CA377FA07D4}" dt="2026-09-05T15:36:26.293" v="98" actId="14100"/>
+          <ac:picMkLst>
+            <pc:docMk/>
+            <pc:sldMk cId="0" sldId="258"/>
+            <ac:picMk id="5" creationId="{00000000-0000-0000-0000-000000000000}"/>
+          </ac:picMkLst>
+        </pc:picChg>
+      </pc:sldChg>
+      <pc:sldChg chg="modSp mod">
+        <pc:chgData name="Mayuresh Piske" userId="aeb3d3e9-2c13-446e-8fc0-83f22db42824" providerId="ADAL" clId="{76688486-0801-4EB8-8479-3CA377FA07D4}" dt="2026-09-05T15:27:57.266" v="54" actId="1076"/>
+        <pc:sldMkLst>
+          <pc:docMk/>
+          <pc:sldMk cId="0" sldId="259"/>
+        </pc:sldMkLst>
+        <pc:spChg chg="mod">
+          <ac:chgData name="Mayuresh Piske" userId="aeb3d3e9-2c13-446e-8fc0-83f22db42824" providerId="ADAL" clId="{76688486-0801-4EB8-8479-3CA377FA07D4}" dt="2026-09-05T15:27:48.018" v="52" actId="1076"/>
+          <ac:spMkLst>
+            <pc:docMk/>
+            <pc:sldMk cId="0" sldId="259"/>
+            <ac:spMk id="2" creationId="{00000000-0000-0000-0000-000000000000}"/>
+          </ac:spMkLst>
+        </pc:spChg>
+        <pc:spChg chg="mod">
+          <ac:chgData name="Mayuresh Piske" userId="aeb3d3e9-2c13-446e-8fc0-83f22db42824" providerId="ADAL" clId="{76688486-0801-4EB8-8479-3CA377FA07D4}" dt="2026-09-05T15:27:57.266" v="54" actId="1076"/>
+          <ac:spMkLst>
+            <pc:docMk/>
+            <pc:sldMk cId="0" sldId="259"/>
+            <ac:spMk id="11" creationId="{CDCA28F5-24ED-C6C5-22BD-9A93D513A93A}"/>
+          </ac:spMkLst>
+        </pc:spChg>
+      </pc:sldChg>
+      <pc:sldChg chg="modSp mod">
+        <pc:chgData name="Mayuresh Piske" userId="aeb3d3e9-2c13-446e-8fc0-83f22db42824" providerId="ADAL" clId="{76688486-0801-4EB8-8479-3CA377FA07D4}" dt="2026-09-05T15:27:41.067" v="49" actId="1076"/>
+        <pc:sldMkLst>
+          <pc:docMk/>
+          <pc:sldMk cId="0" sldId="260"/>
+        </pc:sldMkLst>
+        <pc:spChg chg="mod">
+          <ac:chgData name="Mayuresh Piske" userId="aeb3d3e9-2c13-446e-8fc0-83f22db42824" providerId="ADAL" clId="{76688486-0801-4EB8-8479-3CA377FA07D4}" dt="2026-09-05T15:27:41.067" v="49" actId="1076"/>
+          <ac:spMkLst>
+            <pc:docMk/>
+            <pc:sldMk cId="0" sldId="260"/>
+            <ac:spMk id="25" creationId="{7E55F50A-2D07-CDDF-D02C-81095889BAF9}"/>
+          </ac:spMkLst>
+        </pc:spChg>
+      </pc:sldChg>
+      <pc:sldChg chg="modSp mod">
+        <pc:chgData name="Mayuresh Piske" userId="aeb3d3e9-2c13-446e-8fc0-83f22db42824" providerId="ADAL" clId="{76688486-0801-4EB8-8479-3CA377FA07D4}" dt="2026-09-05T15:27:32.513" v="47" actId="1076"/>
+        <pc:sldMkLst>
+          <pc:docMk/>
+          <pc:sldMk cId="0" sldId="261"/>
+        </pc:sldMkLst>
+        <pc:spChg chg="mod">
+          <ac:chgData name="Mayuresh Piske" userId="aeb3d3e9-2c13-446e-8fc0-83f22db42824" providerId="ADAL" clId="{76688486-0801-4EB8-8479-3CA377FA07D4}" dt="2026-09-05T15:27:32.513" v="47" actId="1076"/>
+          <ac:spMkLst>
+            <pc:docMk/>
+            <pc:sldMk cId="0" sldId="261"/>
+            <ac:spMk id="9" creationId="{FB081541-3697-02EB-CA09-947B1D5C7B05}"/>
+          </ac:spMkLst>
+        </pc:spChg>
+      </pc:sldChg>
+      <pc:sldChg chg="modSp mod">
+        <pc:chgData name="Mayuresh Piske" userId="aeb3d3e9-2c13-446e-8fc0-83f22db42824" providerId="ADAL" clId="{76688486-0801-4EB8-8479-3CA377FA07D4}" dt="2026-09-05T15:27:24.766" v="45" actId="1076"/>
+        <pc:sldMkLst>
+          <pc:docMk/>
+          <pc:sldMk cId="0" sldId="262"/>
+        </pc:sldMkLst>
+        <pc:spChg chg="mod">
+          <ac:chgData name="Mayuresh Piske" userId="aeb3d3e9-2c13-446e-8fc0-83f22db42824" providerId="ADAL" clId="{76688486-0801-4EB8-8479-3CA377FA07D4}" dt="2026-09-05T15:27:24.766" v="45" actId="1076"/>
+          <ac:spMkLst>
+            <pc:docMk/>
+            <pc:sldMk cId="0" sldId="262"/>
+            <ac:spMk id="9" creationId="{3F30E14D-839F-E276-DF2D-B2EF76D28596}"/>
+          </ac:spMkLst>
+        </pc:spChg>
+      </pc:sldChg>
+      <pc:sldChg chg="modSp mod">
+        <pc:chgData name="Mayuresh Piske" userId="aeb3d3e9-2c13-446e-8fc0-83f22db42824" providerId="ADAL" clId="{76688486-0801-4EB8-8479-3CA377FA07D4}" dt="2026-09-05T15:27:16.846" v="43" actId="1076"/>
+        <pc:sldMkLst>
+          <pc:docMk/>
+          <pc:sldMk cId="0" sldId="263"/>
+        </pc:sldMkLst>
+        <pc:spChg chg="mod">
+          <ac:chgData name="Mayuresh Piske" userId="aeb3d3e9-2c13-446e-8fc0-83f22db42824" providerId="ADAL" clId="{76688486-0801-4EB8-8479-3CA377FA07D4}" dt="2026-09-05T15:27:12.699" v="42" actId="1076"/>
+          <ac:spMkLst>
+            <pc:docMk/>
+            <pc:sldMk cId="0" sldId="263"/>
+            <ac:spMk id="2" creationId="{00000000-0000-0000-0000-000000000000}"/>
+          </ac:spMkLst>
+        </pc:spChg>
+        <pc:spChg chg="mod">
+          <ac:chgData name="Mayuresh Piske" userId="aeb3d3e9-2c13-446e-8fc0-83f22db42824" providerId="ADAL" clId="{76688486-0801-4EB8-8479-3CA377FA07D4}" dt="2026-09-05T15:27:16.846" v="43" actId="1076"/>
+          <ac:spMkLst>
+            <pc:docMk/>
+            <pc:sldMk cId="0" sldId="263"/>
+            <ac:spMk id="6" creationId="{C4C2C17A-6560-086A-57BE-9E6D36D66ACA}"/>
+          </ac:spMkLst>
+        </pc:spChg>
+      </pc:sldChg>
+    </pc:docChg>
+  </pc:docChgLst>
+</pc:chgInfo>
+</file>
+
+<file path=ppt/notesMasters/notesMaster1.xml><?xml version="1.0" encoding="utf-8"?>
+<p:notesMaster xmlns:a="http://schemas.openxmlformats.org/drawingml/2006/main" xmlns:r="http://schemas.openxmlformats.org/officeDocument/2006/relationships" xmlns:p="http://schemas.openxmlformats.org/presentationml/2006/main">
+  <p:cSld>
+    <p:bg>
+      <p:bgRef idx="1001">
+        <a:schemeClr val="bg1"/>
+      </p:bgRef>
+    </p:bg>
+    <p:spTree>
+      <p:nvGrpSpPr>
+        <p:cNvPr id="1" name=""/>
+        <p:cNvGrpSpPr/>
+        <p:nvPr/>
+      </p:nvGrpSpPr>
+      <p:grpSpPr>
+        <a:xfrm>
+          <a:off x="0" y="0"/>
+          <a:ext cx="0" cy="0"/>
+          <a:chOff x="0" y="0"/>
+          <a:chExt cx="0" cy="0"/>
+        </a:xfrm>
+      </p:grpSpPr>
+      <p:sp>
+        <p:nvSpPr>
+          <p:cNvPr id="2" name="Header Placeholder 1"/>
+          <p:cNvSpPr>
+            <a:spLocks noGrp="1"/>
+          </p:cNvSpPr>
+          <p:nvPr>
+            <p:ph type="hdr" sz="quarter"/>
+          </p:nvPr>
+        </p:nvSpPr>
+        <p:spPr>
+          <a:xfrm>
+            <a:off x="0" y="0"/>
+            <a:ext cx="2971800" cy="458788"/>
+          </a:xfrm>
+          <a:prstGeom prst="rect">
+            <a:avLst/>
+          </a:prstGeom>
+        </p:spPr>
+        <p:txBody>
+          <a:bodyPr vert="horz" lIns="91440" tIns="45720" rIns="91440" bIns="45720" rtlCol="0"/>
+          <a:lstStyle>
+            <a:lvl1pPr algn="l">
+              <a:defRPr sz="1200"/>
+            </a:lvl1pPr>
+          </a:lstStyle>
+          <a:p>
+            <a:endParaRPr lang="en-IN"/>
+          </a:p>
+        </p:txBody>
+      </p:sp>
+      <p:sp>
+        <p:nvSpPr>
+          <p:cNvPr id="3" name="Date Placeholder 2"/>
+          <p:cNvSpPr>
+            <a:spLocks noGrp="1"/>
+          </p:cNvSpPr>
+          <p:nvPr>
+            <p:ph type="dt" idx="1"/>
+          </p:nvPr>
+        </p:nvSpPr>
+        <p:spPr>
+          <a:xfrm>
+            <a:off x="3884613" y="0"/>
+            <a:ext cx="2971800" cy="458788"/>
+          </a:xfrm>
+          <a:prstGeom prst="rect">
+            <a:avLst/>
+          </a:prstGeom>
+        </p:spPr>
+        <p:txBody>
+          <a:bodyPr vert="horz" lIns="91440" tIns="45720" rIns="91440" bIns="45720" rtlCol="0"/>
+          <a:lstStyle>
+            <a:lvl1pPr algn="r">
+              <a:defRPr sz="1200"/>
+            </a:lvl1pPr>
+          </a:lstStyle>
+          <a:p>
+            <a:fld id="{08CC7E1A-73E7-4392-AC6F-F56983B15E02}" type="datetimeFigureOut">
+              <a:rPr lang="en-IN" smtClean="0"/>
+              <a:t>05-09-2026</a:t>
+            </a:fld>
+            <a:endParaRPr lang="en-IN"/>
+          </a:p>
+        </p:txBody>
+      </p:sp>
+      <p:sp>
+        <p:nvSpPr>
+          <p:cNvPr id="4" name="Slide Image Placeholder 3"/>
+          <p:cNvSpPr>
+            <a:spLocks noGrp="1" noRot="1" noChangeAspect="1"/>
+          </p:cNvSpPr>
+          <p:nvPr>
+            <p:ph type="sldImg" idx="2"/>
+          </p:nvPr>
+        </p:nvSpPr>
+        <p:spPr>
+          <a:xfrm>
+            <a:off x="685800" y="1143000"/>
+            <a:ext cx="5486400" cy="3086100"/>
+          </a:xfrm>
+          <a:prstGeom prst="rect">
+            <a:avLst/>
+          </a:prstGeom>
+          <a:noFill/>
+          <a:ln w="12700">
+            <a:solidFill>
+              <a:prstClr val="black"/>
+            </a:solidFill>
+          </a:ln>
+        </p:spPr>
+        <p:txBody>
+          <a:bodyPr vert="horz" lIns="91440" tIns="45720" rIns="91440" bIns="45720" rtlCol="0" anchor="ctr"/>
+          <a:lstStyle/>
+          <a:p>
+            <a:endParaRPr lang="en-IN"/>
+          </a:p>
+        </p:txBody>
+      </p:sp>
+      <p:sp>
+        <p:nvSpPr>
+          <p:cNvPr id="5" name="Notes Placeholder 4"/>
+          <p:cNvSpPr>
+            <a:spLocks noGrp="1"/>
+          </p:cNvSpPr>
+          <p:nvPr>
+            <p:ph type="body" sz="quarter" idx="3"/>
+          </p:nvPr>
+        </p:nvSpPr>
+        <p:spPr>
+          <a:xfrm>
+            <a:off x="685800" y="4400550"/>
+            <a:ext cx="5486400" cy="3600450"/>
+          </a:xfrm>
+          <a:prstGeom prst="rect">
+            <a:avLst/>
+          </a:prstGeom>
+        </p:spPr>
+        <p:txBody>
+          <a:bodyPr vert="horz" lIns="91440" tIns="45720" rIns="91440" bIns="45720" rtlCol="0"/>
+          <a:lstStyle/>
+          <a:p>
+            <a:pPr lvl="0"/>
+            <a:r>
+              <a:rPr lang="en-GB"/>
+              <a:t>Click to edit Master text styles</a:t>
+            </a:r>
+          </a:p>
+          <a:p>
+            <a:pPr lvl="1"/>
+            <a:r>
+              <a:rPr lang="en-GB"/>
+              <a:t>Second level</a:t>
+            </a:r>
+          </a:p>
+          <a:p>
+            <a:pPr lvl="2"/>
+            <a:r>
+              <a:rPr lang="en-GB"/>
+              <a:t>Third level</a:t>
+            </a:r>
+          </a:p>
+          <a:p>
+            <a:pPr lvl="3"/>
+            <a:r>
+              <a:rPr lang="en-GB"/>
+              <a:t>Fourth level</a:t>
+            </a:r>
+          </a:p>
+          <a:p>
+            <a:pPr lvl="4"/>
+            <a:r>
+              <a:rPr lang="en-GB"/>
+              <a:t>Fifth level</a:t>
+            </a:r>
+            <a:endParaRPr lang="en-IN"/>
+          </a:p>
+        </p:txBody>
+      </p:sp>
+      <p:sp>
+        <p:nvSpPr>
+          <p:cNvPr id="6" name="Footer Placeholder 5"/>
+          <p:cNvSpPr>
+            <a:spLocks noGrp="1"/>
+          </p:cNvSpPr>
+          <p:nvPr>
+            <p:ph type="ftr" sz="quarter" idx="4"/>
+          </p:nvPr>
+        </p:nvSpPr>
+        <p:spPr>
+          <a:xfrm>
+            <a:off x="0" y="8685213"/>
+            <a:ext cx="2971800" cy="458787"/>
+          </a:xfrm>
+          <a:prstGeom prst="rect">
+            <a:avLst/>
+          </a:prstGeom>
+        </p:spPr>
+        <p:txBody>
+          <a:bodyPr vert="horz" lIns="91440" tIns="45720" rIns="91440" bIns="45720" rtlCol="0" anchor="b"/>
+          <a:lstStyle>
+            <a:lvl1pPr algn="l">
+              <a:defRPr sz="1200"/>
+            </a:lvl1pPr>
+          </a:lstStyle>
+          <a:p>
+            <a:endParaRPr lang="en-IN"/>
+          </a:p>
+        </p:txBody>
+      </p:sp>
+      <p:sp>
+        <p:nvSpPr>
+          <p:cNvPr id="7" name="Slide Number Placeholder 6"/>
+          <p:cNvSpPr>
+            <a:spLocks noGrp="1"/>
+          </p:cNvSpPr>
+          <p:nvPr>
+            <p:ph type="sldNum" sz="quarter" idx="5"/>
+          </p:nvPr>
+        </p:nvSpPr>
+        <p:spPr>
+          <a:xfrm>
+            <a:off x="3884613" y="8685213"/>
+            <a:ext cx="2971800" cy="458787"/>
+          </a:xfrm>
+          <a:prstGeom prst="rect">
+            <a:avLst/>
+          </a:prstGeom>
+        </p:spPr>
+        <p:txBody>
+          <a:bodyPr vert="horz" lIns="91440" tIns="45720" rIns="91440" bIns="45720" rtlCol="0" anchor="b"/>
+          <a:lstStyle>
+            <a:lvl1pPr algn="r">
+              <a:defRPr sz="1200"/>
+            </a:lvl1pPr>
+          </a:lstStyle>
+          <a:p>
+            <a:fld id="{515C6A6E-78E3-4131-AA1F-BE872D646191}" type="slidenum">
+              <a:rPr lang="en-IN" smtClean="0"/>
+              <a:t>‹#›</a:t>
+            </a:fld>
+            <a:endParaRPr lang="en-IN"/>
+          </a:p>
+        </p:txBody>
+      </p:sp>
+    </p:spTree>
+    <p:extLst>
+      <p:ext uri="{BB962C8B-B14F-4D97-AF65-F5344CB8AC3E}">
+        <p14:creationId xmlns:p14="http://schemas.microsoft.com/office/powerpoint/2010/main" val="1665279300"/>
+      </p:ext>
+    </p:extLst>
+  </p:cSld>
+  <p:clrMap bg1="lt1" tx1="dk1" bg2="lt2" tx2="dk2" accent1="accent1" accent2="accent2" accent3="accent3" accent4="accent4" accent5="accent5" accent6="accent6" hlink="hlink" folHlink="folHlink"/>
+  <p:notesStyle>
+    <a:lvl1pPr marL="0" algn="l" defTabSz="914400" rtl="0" eaLnBrk="1" latinLnBrk="0" hangingPunct="1">
+      <a:defRPr sz="1200" kern="1200">
+        <a:solidFill>
+          <a:schemeClr val="tx1"/>
+        </a:solidFill>
+        <a:latin typeface="+mn-lt"/>
+        <a:ea typeface="+mn-ea"/>
+        <a:cs typeface="+mn-cs"/>
+      </a:defRPr>
+    </a:lvl1pPr>
+    <a:lvl2pPr marL="457200" algn="l" defTabSz="914400" rtl="0" eaLnBrk="1" latinLnBrk="0" hangingPunct="1">
+      <a:defRPr sz="1200" kern="1200">
+        <a:solidFill>
+          <a:schemeClr val="tx1"/>
+        </a:solidFill>
+        <a:latin typeface="+mn-lt"/>
+        <a:ea typeface="+mn-ea"/>
+        <a:cs typeface="+mn-cs"/>
+      </a:defRPr>
+    </a:lvl2pPr>
+    <a:lvl3pPr marL="914400" algn="l" defTabSz="914400" rtl="0" eaLnBrk="1" latinLnBrk="0" hangingPunct="1">
+      <a:defRPr sz="1200" kern="1200">
+        <a:solidFill>
+          <a:schemeClr val="tx1"/>
+        </a:solidFill>
+        <a:latin typeface="+mn-lt"/>
+        <a:ea typeface="+mn-ea"/>
+        <a:cs typeface="+mn-cs"/>
+      </a:defRPr>
+    </a:lvl3pPr>
+    <a:lvl4pPr marL="1371600" algn="l" defTabSz="914400" rtl="0" eaLnBrk="1" latinLnBrk="0" hangingPunct="1">
+      <a:defRPr sz="1200" kern="1200">
+        <a:solidFill>
+          <a:schemeClr val="tx1"/>
+        </a:solidFill>
+        <a:latin typeface="+mn-lt"/>
+        <a:ea typeface="+mn-ea"/>
+        <a:cs typeface="+mn-cs"/>
+      </a:defRPr>
+    </a:lvl4pPr>
+    <a:lvl5pPr marL="1828800" algn="l" defTabSz="914400" rtl="0" eaLnBrk="1" latinLnBrk="0" hangingPunct="1">
+      <a:defRPr sz="1200" kern="1200">
+        <a:solidFill>
+          <a:schemeClr val="tx1"/>
+        </a:solidFill>
+        <a:latin typeface="+mn-lt"/>
+        <a:ea typeface="+mn-ea"/>
+        <a:cs typeface="+mn-cs"/>
+      </a:defRPr>
+    </a:lvl5pPr>
+    <a:lvl6pPr marL="2286000" algn="l" defTabSz="914400" rtl="0" eaLnBrk="1" latinLnBrk="0" hangingPunct="1">
+      <a:defRPr sz="1200" kern="1200">
+        <a:solidFill>
+          <a:schemeClr val="tx1"/>
+        </a:solidFill>
+        <a:latin typeface="+mn-lt"/>
+        <a:ea typeface="+mn-ea"/>
+        <a:cs typeface="+mn-cs"/>
+      </a:defRPr>
+    </a:lvl6pPr>
+    <a:lvl7pPr marL="2743200" algn="l" defTabSz="914400" rtl="0" eaLnBrk="1" latinLnBrk="0" hangingPunct="1">
+      <a:defRPr sz="1200" kern="1200">
+        <a:solidFill>
+          <a:schemeClr val="tx1"/>
+        </a:solidFill>
+        <a:latin typeface="+mn-lt"/>
+        <a:ea typeface="+mn-ea"/>
+        <a:cs typeface="+mn-cs"/>
+      </a:defRPr>
+    </a:lvl7pPr>
+    <a:lvl8pPr marL="3200400" algn="l" defTabSz="914400" rtl="0" eaLnBrk="1" latinLnBrk="0" hangingPunct="1">
+      <a:defRPr sz="1200" kern="1200">
+        <a:solidFill>
+          <a:schemeClr val="tx1"/>
+        </a:solidFill>
+        <a:latin typeface="+mn-lt"/>
+        <a:ea typeface="+mn-ea"/>
+        <a:cs typeface="+mn-cs"/>
+      </a:defRPr>
+    </a:lvl8pPr>
+    <a:lvl9pPr marL="3657600" algn="l" defTabSz="914400" rtl="0" eaLnBrk="1" latinLnBrk="0" hangingPunct="1">
+      <a:defRPr sz="1200" kern="1200">
+        <a:solidFill>
+          <a:schemeClr val="tx1"/>
+        </a:solidFill>
+        <a:latin typeface="+mn-lt"/>
+        <a:ea typeface="+mn-ea"/>
+        <a:cs typeface="+mn-cs"/>
+      </a:defRPr>
+    </a:lvl9pPr>
+  </p:notesStyle>
+</p:notesMaster>
 </file>
 
 <file path=ppt/slideLayouts/slideLayout1.xml><?xml version="1.0" encoding="utf-8"?>
@@ -152,10 +735,9 @@
           <a:lstStyle/>
           <a:p>
             <a:r>
-              <a:rPr lang="en-US" smtClean="0"/>
+              <a:rPr lang="en-US"/>
               <a:t>Click to edit Master title style</a:t>
             </a:r>
-            <a:endParaRPr lang="en-US"/>
           </a:p>
         </p:txBody>
       </p:sp>
@@ -271,31 +853,30 @@
           </a:lstStyle>
           <a:p>
             <a:r>
+              <a:rPr lang="en-US"/>
+              <a:t>Click to edit Master subtitle style</a:t>
+            </a:r>
+          </a:p>
+        </p:txBody>
+      </p:sp>
+      <p:sp>
+        <p:nvSpPr>
+          <p:cNvPr id="4" name="Date Placeholder 3"/>
+          <p:cNvSpPr>
+            <a:spLocks noGrp="1"/>
+          </p:cNvSpPr>
+          <p:nvPr>
+            <p:ph type="dt" sz="half" idx="10"/>
+          </p:nvPr>
+        </p:nvSpPr>
+        <p:spPr/>
+        <p:txBody>
+          <a:bodyPr/>
+          <a:lstStyle/>
+          <a:p>
+            <a:fld id="{C31A860E-A5C9-4BB3-9D24-03426CEDA1FE}" type="datetime1">
               <a:rPr lang="en-US" smtClean="0"/>
-              <a:t>Click to edit Master subtitle style</a:t>
-            </a:r>
-            <a:endParaRPr lang="en-US"/>
-          </a:p>
-        </p:txBody>
-      </p:sp>
-      <p:sp>
-        <p:nvSpPr>
-          <p:cNvPr id="4" name="Date Placeholder 3"/>
-          <p:cNvSpPr>
-            <a:spLocks noGrp="1"/>
-          </p:cNvSpPr>
-          <p:nvPr>
-            <p:ph type="dt" sz="half" idx="10"/>
-          </p:nvPr>
-        </p:nvSpPr>
-        <p:spPr/>
-        <p:txBody>
-          <a:bodyPr/>
-          <a:lstStyle/>
-          <a:p>
-            <a:fld id="{5BCAD085-E8A6-8845-BD4E-CB4CCA059FC4}" type="datetimeFigureOut">
-              <a:rPr lang="en-US" smtClean="0"/>
-              <a:t>1/27/13</a:t>
+              <a:t>9/5/2026</a:t>
             </a:fld>
             <a:endParaRPr lang="en-US"/>
           </a:p>
@@ -316,7 +897,10 @@
           <a:bodyPr/>
           <a:lstStyle/>
           <a:p>
-            <a:endParaRPr lang="en-US"/>
+            <a:r>
+              <a:rPr lang="en-US"/>
+              <a:t>ClosureCopilot · Mayuresh Piske · © 2026 Microsoft</a:t>
+            </a:r>
           </a:p>
         </p:txBody>
       </p:sp>
@@ -389,83 +973,81 @@
           <a:lstStyle/>
           <a:p>
             <a:r>
+              <a:rPr lang="en-US"/>
+              <a:t>Click to edit Master title style</a:t>
+            </a:r>
+          </a:p>
+        </p:txBody>
+      </p:sp>
+      <p:sp>
+        <p:nvSpPr>
+          <p:cNvPr id="3" name="Vertical Text Placeholder 2"/>
+          <p:cNvSpPr>
+            <a:spLocks noGrp="1"/>
+          </p:cNvSpPr>
+          <p:nvPr>
+            <p:ph type="body" orient="vert" idx="1"/>
+          </p:nvPr>
+        </p:nvSpPr>
+        <p:spPr/>
+        <p:txBody>
+          <a:bodyPr vert="eaVert"/>
+          <a:lstStyle/>
+          <a:p>
+            <a:pPr lvl="0"/>
+            <a:r>
+              <a:rPr lang="en-US"/>
+              <a:t>Click to edit Master text styles</a:t>
+            </a:r>
+          </a:p>
+          <a:p>
+            <a:pPr lvl="1"/>
+            <a:r>
+              <a:rPr lang="en-US"/>
+              <a:t>Second level</a:t>
+            </a:r>
+          </a:p>
+          <a:p>
+            <a:pPr lvl="2"/>
+            <a:r>
+              <a:rPr lang="en-US"/>
+              <a:t>Third level</a:t>
+            </a:r>
+          </a:p>
+          <a:p>
+            <a:pPr lvl="3"/>
+            <a:r>
+              <a:rPr lang="en-US"/>
+              <a:t>Fourth level</a:t>
+            </a:r>
+          </a:p>
+          <a:p>
+            <a:pPr lvl="4"/>
+            <a:r>
+              <a:rPr lang="en-US"/>
+              <a:t>Fifth level</a:t>
+            </a:r>
+          </a:p>
+        </p:txBody>
+      </p:sp>
+      <p:sp>
+        <p:nvSpPr>
+          <p:cNvPr id="4" name="Date Placeholder 3"/>
+          <p:cNvSpPr>
+            <a:spLocks noGrp="1"/>
+          </p:cNvSpPr>
+          <p:nvPr>
+            <p:ph type="dt" sz="half" idx="10"/>
+          </p:nvPr>
+        </p:nvSpPr>
+        <p:spPr/>
+        <p:txBody>
+          <a:bodyPr/>
+          <a:lstStyle/>
+          <a:p>
+            <a:fld id="{E113E97C-F88E-4447-9191-634C0FE55DE7}" type="datetime1">
               <a:rPr lang="en-US" smtClean="0"/>
-              <a:t>Click to edit Master title style</a:t>
-            </a:r>
-            <a:endParaRPr lang="en-US"/>
-          </a:p>
-        </p:txBody>
-      </p:sp>
-      <p:sp>
-        <p:nvSpPr>
-          <p:cNvPr id="3" name="Vertical Text Placeholder 2"/>
-          <p:cNvSpPr>
-            <a:spLocks noGrp="1"/>
-          </p:cNvSpPr>
-          <p:nvPr>
-            <p:ph type="body" orient="vert" idx="1"/>
-          </p:nvPr>
-        </p:nvSpPr>
-        <p:spPr/>
-        <p:txBody>
-          <a:bodyPr vert="eaVert"/>
-          <a:lstStyle/>
-          <a:p>
-            <a:pPr lvl="0"/>
-            <a:r>
-              <a:rPr lang="en-US" smtClean="0"/>
-              <a:t>Click to edit Master text styles</a:t>
-            </a:r>
-          </a:p>
-          <a:p>
-            <a:pPr lvl="1"/>
-            <a:r>
-              <a:rPr lang="en-US" smtClean="0"/>
-              <a:t>Second level</a:t>
-            </a:r>
-          </a:p>
-          <a:p>
-            <a:pPr lvl="2"/>
-            <a:r>
-              <a:rPr lang="en-US" smtClean="0"/>
-              <a:t>Third level</a:t>
-            </a:r>
-          </a:p>
-          <a:p>
-            <a:pPr lvl="3"/>
-            <a:r>
-              <a:rPr lang="en-US" smtClean="0"/>
-              <a:t>Fourth level</a:t>
-            </a:r>
-          </a:p>
-          <a:p>
-            <a:pPr lvl="4"/>
-            <a:r>
-              <a:rPr lang="en-US" smtClean="0"/>
-              <a:t>Fifth level</a:t>
-            </a:r>
-            <a:endParaRPr lang="en-US"/>
-          </a:p>
-        </p:txBody>
-      </p:sp>
-      <p:sp>
-        <p:nvSpPr>
-          <p:cNvPr id="4" name="Date Placeholder 3"/>
-          <p:cNvSpPr>
-            <a:spLocks noGrp="1"/>
-          </p:cNvSpPr>
-          <p:nvPr>
-            <p:ph type="dt" sz="half" idx="10"/>
-          </p:nvPr>
-        </p:nvSpPr>
-        <p:spPr/>
-        <p:txBody>
-          <a:bodyPr/>
-          <a:lstStyle/>
-          <a:p>
-            <a:fld id="{5BCAD085-E8A6-8845-BD4E-CB4CCA059FC4}" type="datetimeFigureOut">
-              <a:rPr lang="en-US" smtClean="0"/>
-              <a:t>1/27/13</a:t>
+              <a:t>9/5/2026</a:t>
             </a:fld>
             <a:endParaRPr lang="en-US"/>
           </a:p>
@@ -486,7 +1068,10 @@
           <a:bodyPr/>
           <a:lstStyle/>
           <a:p>
-            <a:endParaRPr lang="en-US"/>
+            <a:r>
+              <a:rPr lang="en-US"/>
+              <a:t>ClosureCopilot · Mayuresh Piske · © 2026 Microsoft</a:t>
+            </a:r>
           </a:p>
         </p:txBody>
       </p:sp>
@@ -564,10 +1149,9 @@
           <a:lstStyle/>
           <a:p>
             <a:r>
-              <a:rPr lang="en-US" smtClean="0"/>
+              <a:rPr lang="en-US"/>
               <a:t>Click to edit Master title style</a:t>
             </a:r>
-            <a:endParaRPr lang="en-US"/>
           </a:p>
         </p:txBody>
       </p:sp>
@@ -593,59 +1177,58 @@
           <a:p>
             <a:pPr lvl="0"/>
             <a:r>
+              <a:rPr lang="en-US"/>
+              <a:t>Click to edit Master text styles</a:t>
+            </a:r>
+          </a:p>
+          <a:p>
+            <a:pPr lvl="1"/>
+            <a:r>
+              <a:rPr lang="en-US"/>
+              <a:t>Second level</a:t>
+            </a:r>
+          </a:p>
+          <a:p>
+            <a:pPr lvl="2"/>
+            <a:r>
+              <a:rPr lang="en-US"/>
+              <a:t>Third level</a:t>
+            </a:r>
+          </a:p>
+          <a:p>
+            <a:pPr lvl="3"/>
+            <a:r>
+              <a:rPr lang="en-US"/>
+              <a:t>Fourth level</a:t>
+            </a:r>
+          </a:p>
+          <a:p>
+            <a:pPr lvl="4"/>
+            <a:r>
+              <a:rPr lang="en-US"/>
+              <a:t>Fifth level</a:t>
+            </a:r>
+          </a:p>
+        </p:txBody>
+      </p:sp>
+      <p:sp>
+        <p:nvSpPr>
+          <p:cNvPr id="4" name="Date Placeholder 3"/>
+          <p:cNvSpPr>
+            <a:spLocks noGrp="1"/>
+          </p:cNvSpPr>
+          <p:nvPr>
+            <p:ph type="dt" sz="half" idx="10"/>
+          </p:nvPr>
+        </p:nvSpPr>
+        <p:spPr/>
+        <p:txBody>
+          <a:bodyPr/>
+          <a:lstStyle/>
+          <a:p>
+            <a:fld id="{7B1E1322-D978-49E8-9CD9-57D38ACFCED6}" type="datetime1">
               <a:rPr lang="en-US" smtClean="0"/>
-              <a:t>Click to edit Master text styles</a:t>
-            </a:r>
-          </a:p>
-          <a:p>
-            <a:pPr lvl="1"/>
-            <a:r>
-              <a:rPr lang="en-US" smtClean="0"/>
-              <a:t>Second level</a:t>
-            </a:r>
-          </a:p>
-          <a:p>
-            <a:pPr lvl="2"/>
-            <a:r>
-              <a:rPr lang="en-US" smtClean="0"/>
-              <a:t>Third level</a:t>
-            </a:r>
-          </a:p>
-          <a:p>
-            <a:pPr lvl="3"/>
-            <a:r>
-              <a:rPr lang="en-US" smtClean="0"/>
-              <a:t>Fourth level</a:t>
-            </a:r>
-          </a:p>
-          <a:p>
-            <a:pPr lvl="4"/>
-            <a:r>
-              <a:rPr lang="en-US" smtClean="0"/>
-              <a:t>Fifth level</a:t>
-            </a:r>
-            <a:endParaRPr lang="en-US"/>
-          </a:p>
-        </p:txBody>
-      </p:sp>
-      <p:sp>
-        <p:nvSpPr>
-          <p:cNvPr id="4" name="Date Placeholder 3"/>
-          <p:cNvSpPr>
-            <a:spLocks noGrp="1"/>
-          </p:cNvSpPr>
-          <p:nvPr>
-            <p:ph type="dt" sz="half" idx="10"/>
-          </p:nvPr>
-        </p:nvSpPr>
-        <p:spPr/>
-        <p:txBody>
-          <a:bodyPr/>
-          <a:lstStyle/>
-          <a:p>
-            <a:fld id="{5BCAD085-E8A6-8845-BD4E-CB4CCA059FC4}" type="datetimeFigureOut">
-              <a:rPr lang="en-US" smtClean="0"/>
-              <a:t>1/27/13</a:t>
+              <a:t>9/5/2026</a:t>
             </a:fld>
             <a:endParaRPr lang="en-US"/>
           </a:p>
@@ -666,7 +1249,10 @@
           <a:bodyPr/>
           <a:lstStyle/>
           <a:p>
-            <a:endParaRPr lang="en-US"/>
+            <a:r>
+              <a:rPr lang="en-US"/>
+              <a:t>ClosureCopilot · Mayuresh Piske · © 2026 Microsoft</a:t>
+            </a:r>
           </a:p>
         </p:txBody>
       </p:sp>
@@ -739,83 +1325,81 @@
           <a:lstStyle/>
           <a:p>
             <a:r>
+              <a:rPr lang="en-US"/>
+              <a:t>Click to edit Master title style</a:t>
+            </a:r>
+          </a:p>
+        </p:txBody>
+      </p:sp>
+      <p:sp>
+        <p:nvSpPr>
+          <p:cNvPr id="3" name="Content Placeholder 2"/>
+          <p:cNvSpPr>
+            <a:spLocks noGrp="1"/>
+          </p:cNvSpPr>
+          <p:nvPr>
+            <p:ph idx="1"/>
+          </p:nvPr>
+        </p:nvSpPr>
+        <p:spPr/>
+        <p:txBody>
+          <a:bodyPr/>
+          <a:lstStyle/>
+          <a:p>
+            <a:pPr lvl="0"/>
+            <a:r>
+              <a:rPr lang="en-US"/>
+              <a:t>Click to edit Master text styles</a:t>
+            </a:r>
+          </a:p>
+          <a:p>
+            <a:pPr lvl="1"/>
+            <a:r>
+              <a:rPr lang="en-US"/>
+              <a:t>Second level</a:t>
+            </a:r>
+          </a:p>
+          <a:p>
+            <a:pPr lvl="2"/>
+            <a:r>
+              <a:rPr lang="en-US"/>
+              <a:t>Third level</a:t>
+            </a:r>
+          </a:p>
+          <a:p>
+            <a:pPr lvl="3"/>
+            <a:r>
+              <a:rPr lang="en-US"/>
+              <a:t>Fourth level</a:t>
+            </a:r>
+          </a:p>
+          <a:p>
+            <a:pPr lvl="4"/>
+            <a:r>
+              <a:rPr lang="en-US"/>
+              <a:t>Fifth level</a:t>
+            </a:r>
+          </a:p>
+        </p:txBody>
+      </p:sp>
+      <p:sp>
+        <p:nvSpPr>
+          <p:cNvPr id="4" name="Date Placeholder 3"/>
+          <p:cNvSpPr>
+            <a:spLocks noGrp="1"/>
+          </p:cNvSpPr>
+          <p:nvPr>
+            <p:ph type="dt" sz="half" idx="10"/>
+          </p:nvPr>
+        </p:nvSpPr>
+        <p:spPr/>
+        <p:txBody>
+          <a:bodyPr/>
+          <a:lstStyle/>
+          <a:p>
+            <a:fld id="{14366139-1F27-41D5-A69B-CA0FBF3AE9E0}" type="datetime1">
               <a:rPr lang="en-US" smtClean="0"/>
-              <a:t>Click to edit Master title style</a:t>
-            </a:r>
-            <a:endParaRPr lang="en-US"/>
-          </a:p>
-        </p:txBody>
-      </p:sp>
-      <p:sp>
-        <p:nvSpPr>
-          <p:cNvPr id="3" name="Content Placeholder 2"/>
-          <p:cNvSpPr>
-            <a:spLocks noGrp="1"/>
-          </p:cNvSpPr>
-          <p:nvPr>
-            <p:ph idx="1"/>
-          </p:nvPr>
-        </p:nvSpPr>
-        <p:spPr/>
-        <p:txBody>
-          <a:bodyPr/>
-          <a:lstStyle/>
-          <a:p>
-            <a:pPr lvl="0"/>
-            <a:r>
-              <a:rPr lang="en-US" smtClean="0"/>
-              <a:t>Click to edit Master text styles</a:t>
-            </a:r>
-          </a:p>
-          <a:p>
-            <a:pPr lvl="1"/>
-            <a:r>
-              <a:rPr lang="en-US" smtClean="0"/>
-              <a:t>Second level</a:t>
-            </a:r>
-          </a:p>
-          <a:p>
-            <a:pPr lvl="2"/>
-            <a:r>
-              <a:rPr lang="en-US" smtClean="0"/>
-              <a:t>Third level</a:t>
-            </a:r>
-          </a:p>
-          <a:p>
-            <a:pPr lvl="3"/>
-            <a:r>
-              <a:rPr lang="en-US" smtClean="0"/>
-              <a:t>Fourth level</a:t>
-            </a:r>
-          </a:p>
-          <a:p>
-            <a:pPr lvl="4"/>
-            <a:r>
-              <a:rPr lang="en-US" smtClean="0"/>
-              <a:t>Fifth level</a:t>
-            </a:r>
-            <a:endParaRPr lang="en-US"/>
-          </a:p>
-        </p:txBody>
-      </p:sp>
-      <p:sp>
-        <p:nvSpPr>
-          <p:cNvPr id="4" name="Date Placeholder 3"/>
-          <p:cNvSpPr>
-            <a:spLocks noGrp="1"/>
-          </p:cNvSpPr>
-          <p:nvPr>
-            <p:ph type="dt" sz="half" idx="10"/>
-          </p:nvPr>
-        </p:nvSpPr>
-        <p:spPr/>
-        <p:txBody>
-          <a:bodyPr/>
-          <a:lstStyle/>
-          <a:p>
-            <a:fld id="{5BCAD085-E8A6-8845-BD4E-CB4CCA059FC4}" type="datetimeFigureOut">
-              <a:rPr lang="en-US" smtClean="0"/>
-              <a:t>1/27/13</a:t>
+              <a:t>9/5/2026</a:t>
             </a:fld>
             <a:endParaRPr lang="en-US"/>
           </a:p>
@@ -836,7 +1420,10 @@
           <a:bodyPr/>
           <a:lstStyle/>
           <a:p>
-            <a:endParaRPr lang="en-US"/>
+            <a:r>
+              <a:rPr lang="en-US"/>
+              <a:t>ClosureCopilot · Mayuresh Piske · © 2026 Microsoft</a:t>
+            </a:r>
           </a:p>
         </p:txBody>
       </p:sp>
@@ -918,10 +1505,9 @@
           </a:lstStyle>
           <a:p>
             <a:r>
-              <a:rPr lang="en-US" smtClean="0"/>
+              <a:rPr lang="en-US"/>
               <a:t>Click to edit Master title style</a:t>
             </a:r>
-            <a:endParaRPr lang="en-US"/>
           </a:p>
         </p:txBody>
       </p:sp>
@@ -1038,30 +1624,30 @@
           <a:p>
             <a:pPr lvl="0"/>
             <a:r>
+              <a:rPr lang="en-US"/>
+              <a:t>Click to edit Master text styles</a:t>
+            </a:r>
+          </a:p>
+        </p:txBody>
+      </p:sp>
+      <p:sp>
+        <p:nvSpPr>
+          <p:cNvPr id="4" name="Date Placeholder 3"/>
+          <p:cNvSpPr>
+            <a:spLocks noGrp="1"/>
+          </p:cNvSpPr>
+          <p:nvPr>
+            <p:ph type="dt" sz="half" idx="10"/>
+          </p:nvPr>
+        </p:nvSpPr>
+        <p:spPr/>
+        <p:txBody>
+          <a:bodyPr/>
+          <a:lstStyle/>
+          <a:p>
+            <a:fld id="{F4AD9446-3569-482E-B95D-099B6825A3EA}" type="datetime1">
               <a:rPr lang="en-US" smtClean="0"/>
-              <a:t>Click to edit Master text styles</a:t>
-            </a:r>
-          </a:p>
-        </p:txBody>
-      </p:sp>
-      <p:sp>
-        <p:nvSpPr>
-          <p:cNvPr id="4" name="Date Placeholder 3"/>
-          <p:cNvSpPr>
-            <a:spLocks noGrp="1"/>
-          </p:cNvSpPr>
-          <p:nvPr>
-            <p:ph type="dt" sz="half" idx="10"/>
-          </p:nvPr>
-        </p:nvSpPr>
-        <p:spPr/>
-        <p:txBody>
-          <a:bodyPr/>
-          <a:lstStyle/>
-          <a:p>
-            <a:fld id="{5BCAD085-E8A6-8845-BD4E-CB4CCA059FC4}" type="datetimeFigureOut">
-              <a:rPr lang="en-US" smtClean="0"/>
-              <a:t>1/27/13</a:t>
+              <a:t>9/5/2026</a:t>
             </a:fld>
             <a:endParaRPr lang="en-US"/>
           </a:p>
@@ -1082,7 +1668,10 @@
           <a:bodyPr/>
           <a:lstStyle/>
           <a:p>
-            <a:endParaRPr lang="en-US"/>
+            <a:r>
+              <a:rPr lang="en-US"/>
+              <a:t>ClosureCopilot · Mayuresh Piske · © 2026 Microsoft</a:t>
+            </a:r>
           </a:p>
         </p:txBody>
       </p:sp>
@@ -1155,10 +1744,9 @@
           <a:lstStyle/>
           <a:p>
             <a:r>
-              <a:rPr lang="en-US" smtClean="0"/>
+              <a:rPr lang="en-US"/>
               <a:t>Click to edit Master title style</a:t>
             </a:r>
-            <a:endParaRPr lang="en-US"/>
           </a:p>
         </p:txBody>
       </p:sp>
@@ -1212,38 +1800,37 @@
           <a:p>
             <a:pPr lvl="0"/>
             <a:r>
-              <a:rPr lang="en-US" smtClean="0"/>
+              <a:rPr lang="en-US"/>
               <a:t>Click to edit Master text styles</a:t>
             </a:r>
           </a:p>
           <a:p>
             <a:pPr lvl="1"/>
             <a:r>
-              <a:rPr lang="en-US" smtClean="0"/>
+              <a:rPr lang="en-US"/>
               <a:t>Second level</a:t>
             </a:r>
           </a:p>
           <a:p>
             <a:pPr lvl="2"/>
             <a:r>
-              <a:rPr lang="en-US" smtClean="0"/>
+              <a:rPr lang="en-US"/>
               <a:t>Third level</a:t>
             </a:r>
           </a:p>
           <a:p>
             <a:pPr lvl="3"/>
             <a:r>
-              <a:rPr lang="en-US" smtClean="0"/>
+              <a:rPr lang="en-US"/>
               <a:t>Fourth level</a:t>
             </a:r>
           </a:p>
           <a:p>
             <a:pPr lvl="4"/>
             <a:r>
-              <a:rPr lang="en-US" smtClean="0"/>
+              <a:rPr lang="en-US"/>
               <a:t>Fifth level</a:t>
             </a:r>
-            <a:endParaRPr lang="en-US"/>
           </a:p>
         </p:txBody>
       </p:sp>
@@ -1297,59 +1884,58 @@
           <a:p>
             <a:pPr lvl="0"/>
             <a:r>
+              <a:rPr lang="en-US"/>
+              <a:t>Click to edit Master text styles</a:t>
+            </a:r>
+          </a:p>
+          <a:p>
+            <a:pPr lvl="1"/>
+            <a:r>
+              <a:rPr lang="en-US"/>
+              <a:t>Second level</a:t>
+            </a:r>
+          </a:p>
+          <a:p>
+            <a:pPr lvl="2"/>
+            <a:r>
+              <a:rPr lang="en-US"/>
+              <a:t>Third level</a:t>
+            </a:r>
+          </a:p>
+          <a:p>
+            <a:pPr lvl="3"/>
+            <a:r>
+              <a:rPr lang="en-US"/>
+              <a:t>Fourth level</a:t>
+            </a:r>
+          </a:p>
+          <a:p>
+            <a:pPr lvl="4"/>
+            <a:r>
+              <a:rPr lang="en-US"/>
+              <a:t>Fifth level</a:t>
+            </a:r>
+          </a:p>
+        </p:txBody>
+      </p:sp>
+      <p:sp>
+        <p:nvSpPr>
+          <p:cNvPr id="5" name="Date Placeholder 4"/>
+          <p:cNvSpPr>
+            <a:spLocks noGrp="1"/>
+          </p:cNvSpPr>
+          <p:nvPr>
+            <p:ph type="dt" sz="half" idx="10"/>
+          </p:nvPr>
+        </p:nvSpPr>
+        <p:spPr/>
+        <p:txBody>
+          <a:bodyPr/>
+          <a:lstStyle/>
+          <a:p>
+            <a:fld id="{1AA2D408-C22F-4865-A74C-8E62198A75B9}" type="datetime1">
               <a:rPr lang="en-US" smtClean="0"/>
-              <a:t>Click to edit Master text styles</a:t>
-            </a:r>
-          </a:p>
-          <a:p>
-            <a:pPr lvl="1"/>
-            <a:r>
-              <a:rPr lang="en-US" smtClean="0"/>
-              <a:t>Second level</a:t>
-            </a:r>
-          </a:p>
-          <a:p>
-            <a:pPr lvl="2"/>
-            <a:r>
-              <a:rPr lang="en-US" smtClean="0"/>
-              <a:t>Third level</a:t>
-            </a:r>
-          </a:p>
-          <a:p>
-            <a:pPr lvl="3"/>
-            <a:r>
-              <a:rPr lang="en-US" smtClean="0"/>
-              <a:t>Fourth level</a:t>
-            </a:r>
-          </a:p>
-          <a:p>
-            <a:pPr lvl="4"/>
-            <a:r>
-              <a:rPr lang="en-US" smtClean="0"/>
-              <a:t>Fifth level</a:t>
-            </a:r>
-            <a:endParaRPr lang="en-US"/>
-          </a:p>
-        </p:txBody>
-      </p:sp>
-      <p:sp>
-        <p:nvSpPr>
-          <p:cNvPr id="5" name="Date Placeholder 4"/>
-          <p:cNvSpPr>
-            <a:spLocks noGrp="1"/>
-          </p:cNvSpPr>
-          <p:nvPr>
-            <p:ph type="dt" sz="half" idx="10"/>
-          </p:nvPr>
-        </p:nvSpPr>
-        <p:spPr/>
-        <p:txBody>
-          <a:bodyPr/>
-          <a:lstStyle/>
-          <a:p>
-            <a:fld id="{5BCAD085-E8A6-8845-BD4E-CB4CCA059FC4}" type="datetimeFigureOut">
-              <a:rPr lang="en-US" smtClean="0"/>
-              <a:t>1/27/13</a:t>
+              <a:t>9/5/2026</a:t>
             </a:fld>
             <a:endParaRPr lang="en-US"/>
           </a:p>
@@ -1370,7 +1956,10 @@
           <a:bodyPr/>
           <a:lstStyle/>
           <a:p>
-            <a:endParaRPr lang="en-US"/>
+            <a:r>
+              <a:rPr lang="en-US"/>
+              <a:t>ClosureCopilot · Mayuresh Piske · © 2026 Microsoft</a:t>
+            </a:r>
           </a:p>
         </p:txBody>
       </p:sp>
@@ -1447,10 +2036,9 @@
           </a:lstStyle>
           <a:p>
             <a:r>
-              <a:rPr lang="en-US" smtClean="0"/>
+              <a:rPr lang="en-US"/>
               <a:t>Click to edit Master title style</a:t>
             </a:r>
-            <a:endParaRPr lang="en-US"/>
           </a:p>
         </p:txBody>
       </p:sp>
@@ -1513,7 +2101,7 @@
           <a:p>
             <a:pPr lvl="0"/>
             <a:r>
-              <a:rPr lang="en-US" smtClean="0"/>
+              <a:rPr lang="en-US"/>
               <a:t>Click to edit Master text styles</a:t>
             </a:r>
           </a:p>
@@ -1569,38 +2157,37 @@
           <a:p>
             <a:pPr lvl="0"/>
             <a:r>
-              <a:rPr lang="en-US" smtClean="0"/>
+              <a:rPr lang="en-US"/>
               <a:t>Click to edit Master text styles</a:t>
             </a:r>
           </a:p>
           <a:p>
             <a:pPr lvl="1"/>
             <a:r>
-              <a:rPr lang="en-US" smtClean="0"/>
+              <a:rPr lang="en-US"/>
               <a:t>Second level</a:t>
             </a:r>
           </a:p>
           <a:p>
             <a:pPr lvl="2"/>
             <a:r>
-              <a:rPr lang="en-US" smtClean="0"/>
+              <a:rPr lang="en-US"/>
               <a:t>Third level</a:t>
             </a:r>
           </a:p>
           <a:p>
             <a:pPr lvl="3"/>
             <a:r>
-              <a:rPr lang="en-US" smtClean="0"/>
+              <a:rPr lang="en-US"/>
               <a:t>Fourth level</a:t>
             </a:r>
           </a:p>
           <a:p>
             <a:pPr lvl="4"/>
             <a:r>
-              <a:rPr lang="en-US" smtClean="0"/>
+              <a:rPr lang="en-US"/>
               <a:t>Fifth level</a:t>
             </a:r>
-            <a:endParaRPr lang="en-US"/>
           </a:p>
         </p:txBody>
       </p:sp>
@@ -1663,7 +2250,7 @@
           <a:p>
             <a:pPr lvl="0"/>
             <a:r>
-              <a:rPr lang="en-US" smtClean="0"/>
+              <a:rPr lang="en-US"/>
               <a:t>Click to edit Master text styles</a:t>
             </a:r>
           </a:p>
@@ -1719,59 +2306,58 @@
           <a:p>
             <a:pPr lvl="0"/>
             <a:r>
+              <a:rPr lang="en-US"/>
+              <a:t>Click to edit Master text styles</a:t>
+            </a:r>
+          </a:p>
+          <a:p>
+            <a:pPr lvl="1"/>
+            <a:r>
+              <a:rPr lang="en-US"/>
+              <a:t>Second level</a:t>
+            </a:r>
+          </a:p>
+          <a:p>
+            <a:pPr lvl="2"/>
+            <a:r>
+              <a:rPr lang="en-US"/>
+              <a:t>Third level</a:t>
+            </a:r>
+          </a:p>
+          <a:p>
+            <a:pPr lvl="3"/>
+            <a:r>
+              <a:rPr lang="en-US"/>
+              <a:t>Fourth level</a:t>
+            </a:r>
+          </a:p>
+          <a:p>
+            <a:pPr lvl="4"/>
+            <a:r>
+              <a:rPr lang="en-US"/>
+              <a:t>Fifth level</a:t>
+            </a:r>
+          </a:p>
+        </p:txBody>
+      </p:sp>
+      <p:sp>
+        <p:nvSpPr>
+          <p:cNvPr id="7" name="Date Placeholder 6"/>
+          <p:cNvSpPr>
+            <a:spLocks noGrp="1"/>
+          </p:cNvSpPr>
+          <p:nvPr>
+            <p:ph type="dt" sz="half" idx="10"/>
+          </p:nvPr>
+        </p:nvSpPr>
+        <p:spPr/>
+        <p:txBody>
+          <a:bodyPr/>
+          <a:lstStyle/>
+          <a:p>
+            <a:fld id="{7FC42C51-E0FA-49C8-BD77-1A8E329A1E2C}" type="datetime1">
               <a:rPr lang="en-US" smtClean="0"/>
-              <a:t>Click to edit Master text styles</a:t>
-            </a:r>
-          </a:p>
-          <a:p>
-            <a:pPr lvl="1"/>
-            <a:r>
-              <a:rPr lang="en-US" smtClean="0"/>
-              <a:t>Second level</a:t>
-            </a:r>
-          </a:p>
-          <a:p>
-            <a:pPr lvl="2"/>
-            <a:r>
-              <a:rPr lang="en-US" smtClean="0"/>
-              <a:t>Third level</a:t>
-            </a:r>
-          </a:p>
-          <a:p>
-            <a:pPr lvl="3"/>
-            <a:r>
-              <a:rPr lang="en-US" smtClean="0"/>
-              <a:t>Fourth level</a:t>
-            </a:r>
-          </a:p>
-          <a:p>
-            <a:pPr lvl="4"/>
-            <a:r>
-              <a:rPr lang="en-US" smtClean="0"/>
-              <a:t>Fifth level</a:t>
-            </a:r>
-            <a:endParaRPr lang="en-US"/>
-          </a:p>
-        </p:txBody>
-      </p:sp>
-      <p:sp>
-        <p:nvSpPr>
-          <p:cNvPr id="7" name="Date Placeholder 6"/>
-          <p:cNvSpPr>
-            <a:spLocks noGrp="1"/>
-          </p:cNvSpPr>
-          <p:nvPr>
-            <p:ph type="dt" sz="half" idx="10"/>
-          </p:nvPr>
-        </p:nvSpPr>
-        <p:spPr/>
-        <p:txBody>
-          <a:bodyPr/>
-          <a:lstStyle/>
-          <a:p>
-            <a:fld id="{5BCAD085-E8A6-8845-BD4E-CB4CCA059FC4}" type="datetimeFigureOut">
-              <a:rPr lang="en-US" smtClean="0"/>
-              <a:t>1/27/13</a:t>
+              <a:t>9/5/2026</a:t>
             </a:fld>
             <a:endParaRPr lang="en-US"/>
           </a:p>
@@ -1792,7 +2378,10 @@
           <a:bodyPr/>
           <a:lstStyle/>
           <a:p>
-            <a:endParaRPr lang="en-US"/>
+            <a:r>
+              <a:rPr lang="en-US"/>
+              <a:t>ClosureCopilot · Mayuresh Piske · © 2026 Microsoft</a:t>
+            </a:r>
           </a:p>
         </p:txBody>
       </p:sp>
@@ -1865,31 +2454,30 @@
           <a:lstStyle/>
           <a:p>
             <a:r>
+              <a:rPr lang="en-US"/>
+              <a:t>Click to edit Master title style</a:t>
+            </a:r>
+          </a:p>
+        </p:txBody>
+      </p:sp>
+      <p:sp>
+        <p:nvSpPr>
+          <p:cNvPr id="3" name="Date Placeholder 2"/>
+          <p:cNvSpPr>
+            <a:spLocks noGrp="1"/>
+          </p:cNvSpPr>
+          <p:nvPr>
+            <p:ph type="dt" sz="half" idx="10"/>
+          </p:nvPr>
+        </p:nvSpPr>
+        <p:spPr/>
+        <p:txBody>
+          <a:bodyPr/>
+          <a:lstStyle/>
+          <a:p>
+            <a:fld id="{42FEB809-D8AE-458D-A09F-EC991CDFAAF4}" type="datetime1">
               <a:rPr lang="en-US" smtClean="0"/>
-              <a:t>Click to edit Master title style</a:t>
-            </a:r>
-            <a:endParaRPr lang="en-US"/>
-          </a:p>
-        </p:txBody>
-      </p:sp>
-      <p:sp>
-        <p:nvSpPr>
-          <p:cNvPr id="3" name="Date Placeholder 2"/>
-          <p:cNvSpPr>
-            <a:spLocks noGrp="1"/>
-          </p:cNvSpPr>
-          <p:nvPr>
-            <p:ph type="dt" sz="half" idx="10"/>
-          </p:nvPr>
-        </p:nvSpPr>
-        <p:spPr/>
-        <p:txBody>
-          <a:bodyPr/>
-          <a:lstStyle/>
-          <a:p>
-            <a:fld id="{5BCAD085-E8A6-8845-BD4E-CB4CCA059FC4}" type="datetimeFigureOut">
-              <a:rPr lang="en-US" smtClean="0"/>
-              <a:t>1/27/13</a:t>
+              <a:t>9/5/2026</a:t>
             </a:fld>
             <a:endParaRPr lang="en-US"/>
           </a:p>
@@ -1910,7 +2498,10 @@
           <a:bodyPr/>
           <a:lstStyle/>
           <a:p>
-            <a:endParaRPr lang="en-US"/>
+            <a:r>
+              <a:rPr lang="en-US"/>
+              <a:t>ClosureCopilot · Mayuresh Piske · © 2026 Microsoft</a:t>
+            </a:r>
           </a:p>
         </p:txBody>
       </p:sp>
@@ -1982,9 +2573,9 @@
           <a:bodyPr/>
           <a:lstStyle/>
           <a:p>
-            <a:fld id="{5BCAD085-E8A6-8845-BD4E-CB4CCA059FC4}" type="datetimeFigureOut">
+            <a:fld id="{AC27DD57-8BD2-4ABC-907F-600A7AE12FA9}" type="datetime1">
               <a:rPr lang="en-US" smtClean="0"/>
-              <a:t>1/27/13</a:t>
+              <a:t>9/5/2026</a:t>
             </a:fld>
             <a:endParaRPr lang="en-US"/>
           </a:p>
@@ -2005,7 +2596,10 @@
           <a:bodyPr/>
           <a:lstStyle/>
           <a:p>
-            <a:endParaRPr lang="en-US"/>
+            <a:r>
+              <a:rPr lang="en-US"/>
+              <a:t>ClosureCopilot · Mayuresh Piske · © 2026 Microsoft</a:t>
+            </a:r>
           </a:p>
         </p:txBody>
       </p:sp>
@@ -2087,10 +2681,9 @@
           </a:lstStyle>
           <a:p>
             <a:r>
-              <a:rPr lang="en-US" smtClean="0"/>
+              <a:rPr lang="en-US"/>
               <a:t>Click to edit Master title style</a:t>
             </a:r>
-            <a:endParaRPr lang="en-US"/>
           </a:p>
         </p:txBody>
       </p:sp>
@@ -2144,38 +2737,37 @@
           <a:p>
             <a:pPr lvl="0"/>
             <a:r>
-              <a:rPr lang="en-US" smtClean="0"/>
+              <a:rPr lang="en-US"/>
               <a:t>Click to edit Master text styles</a:t>
             </a:r>
           </a:p>
           <a:p>
             <a:pPr lvl="1"/>
             <a:r>
-              <a:rPr lang="en-US" smtClean="0"/>
+              <a:rPr lang="en-US"/>
               <a:t>Second level</a:t>
             </a:r>
           </a:p>
           <a:p>
             <a:pPr lvl="2"/>
             <a:r>
-              <a:rPr lang="en-US" smtClean="0"/>
+              <a:rPr lang="en-US"/>
               <a:t>Third level</a:t>
             </a:r>
           </a:p>
           <a:p>
             <a:pPr lvl="3"/>
             <a:r>
-              <a:rPr lang="en-US" smtClean="0"/>
+              <a:rPr lang="en-US"/>
               <a:t>Fourth level</a:t>
             </a:r>
           </a:p>
           <a:p>
             <a:pPr lvl="4"/>
             <a:r>
-              <a:rPr lang="en-US" smtClean="0"/>
+              <a:rPr lang="en-US"/>
               <a:t>Fifth level</a:t>
             </a:r>
-            <a:endParaRPr lang="en-US"/>
           </a:p>
         </p:txBody>
       </p:sp>
@@ -2238,30 +2830,30 @@
           <a:p>
             <a:pPr lvl="0"/>
             <a:r>
+              <a:rPr lang="en-US"/>
+              <a:t>Click to edit Master text styles</a:t>
+            </a:r>
+          </a:p>
+        </p:txBody>
+      </p:sp>
+      <p:sp>
+        <p:nvSpPr>
+          <p:cNvPr id="5" name="Date Placeholder 4"/>
+          <p:cNvSpPr>
+            <a:spLocks noGrp="1"/>
+          </p:cNvSpPr>
+          <p:nvPr>
+            <p:ph type="dt" sz="half" idx="10"/>
+          </p:nvPr>
+        </p:nvSpPr>
+        <p:spPr/>
+        <p:txBody>
+          <a:bodyPr/>
+          <a:lstStyle/>
+          <a:p>
+            <a:fld id="{05D9FBC0-417F-4E6F-BB0A-C044624887C5}" type="datetime1">
               <a:rPr lang="en-US" smtClean="0"/>
-              <a:t>Click to edit Master text styles</a:t>
-            </a:r>
-          </a:p>
-        </p:txBody>
-      </p:sp>
-      <p:sp>
-        <p:nvSpPr>
-          <p:cNvPr id="5" name="Date Placeholder 4"/>
-          <p:cNvSpPr>
-            <a:spLocks noGrp="1"/>
-          </p:cNvSpPr>
-          <p:nvPr>
-            <p:ph type="dt" sz="half" idx="10"/>
-          </p:nvPr>
-        </p:nvSpPr>
-        <p:spPr/>
-        <p:txBody>
-          <a:bodyPr/>
-          <a:lstStyle/>
-          <a:p>
-            <a:fld id="{5BCAD085-E8A6-8845-BD4E-CB4CCA059FC4}" type="datetimeFigureOut">
-              <a:rPr lang="en-US" smtClean="0"/>
-              <a:t>1/27/13</a:t>
+              <a:t>9/5/2026</a:t>
             </a:fld>
             <a:endParaRPr lang="en-US"/>
           </a:p>
@@ -2282,7 +2874,10 @@
           <a:bodyPr/>
           <a:lstStyle/>
           <a:p>
-            <a:endParaRPr lang="en-US"/>
+            <a:r>
+              <a:rPr lang="en-US"/>
+              <a:t>ClosureCopilot · Mayuresh Piske · © 2026 Microsoft</a:t>
+            </a:r>
           </a:p>
         </p:txBody>
       </p:sp>
@@ -2364,10 +2959,9 @@
           </a:lstStyle>
           <a:p>
             <a:r>
-              <a:rPr lang="en-US" smtClean="0"/>
+              <a:rPr lang="en-US"/>
               <a:t>Click to edit Master title style</a:t>
             </a:r>
-            <a:endParaRPr lang="en-US"/>
           </a:p>
         </p:txBody>
       </p:sp>
@@ -2491,30 +3085,30 @@
           <a:p>
             <a:pPr lvl="0"/>
             <a:r>
+              <a:rPr lang="en-US"/>
+              <a:t>Click to edit Master text styles</a:t>
+            </a:r>
+          </a:p>
+        </p:txBody>
+      </p:sp>
+      <p:sp>
+        <p:nvSpPr>
+          <p:cNvPr id="5" name="Date Placeholder 4"/>
+          <p:cNvSpPr>
+            <a:spLocks noGrp="1"/>
+          </p:cNvSpPr>
+          <p:nvPr>
+            <p:ph type="dt" sz="half" idx="10"/>
+          </p:nvPr>
+        </p:nvSpPr>
+        <p:spPr/>
+        <p:txBody>
+          <a:bodyPr/>
+          <a:lstStyle/>
+          <a:p>
+            <a:fld id="{10E24268-1955-4D60-8C2B-6482ABF32B4B}" type="datetime1">
               <a:rPr lang="en-US" smtClean="0"/>
-              <a:t>Click to edit Master text styles</a:t>
-            </a:r>
-          </a:p>
-        </p:txBody>
-      </p:sp>
-      <p:sp>
-        <p:nvSpPr>
-          <p:cNvPr id="5" name="Date Placeholder 4"/>
-          <p:cNvSpPr>
-            <a:spLocks noGrp="1"/>
-          </p:cNvSpPr>
-          <p:nvPr>
-            <p:ph type="dt" sz="half" idx="10"/>
-          </p:nvPr>
-        </p:nvSpPr>
-        <p:spPr/>
-        <p:txBody>
-          <a:bodyPr/>
-          <a:lstStyle/>
-          <a:p>
-            <a:fld id="{5BCAD085-E8A6-8845-BD4E-CB4CCA059FC4}" type="datetimeFigureOut">
-              <a:rPr lang="en-US" smtClean="0"/>
-              <a:t>1/27/13</a:t>
+              <a:t>9/5/2026</a:t>
             </a:fld>
             <a:endParaRPr lang="en-US"/>
           </a:p>
@@ -2535,7 +3129,10 @@
           <a:bodyPr/>
           <a:lstStyle/>
           <a:p>
-            <a:endParaRPr lang="en-US"/>
+            <a:r>
+              <a:rPr lang="en-US"/>
+              <a:t>ClosureCopilot · Mayuresh Piske · © 2026 Microsoft</a:t>
+            </a:r>
           </a:p>
         </p:txBody>
       </p:sp>
@@ -2623,10 +3220,9 @@
           <a:lstStyle/>
           <a:p>
             <a:r>
-              <a:rPr lang="en-US" smtClean="0"/>
+              <a:rPr lang="en-US"/>
               <a:t>Click to edit Master title style</a:t>
             </a:r>
-            <a:endParaRPr lang="en-US"/>
           </a:p>
         </p:txBody>
       </p:sp>
@@ -2657,38 +3253,37 @@
           <a:p>
             <a:pPr lvl="0"/>
             <a:r>
-              <a:rPr lang="en-US" smtClean="0"/>
+              <a:rPr lang="en-US"/>
               <a:t>Click to edit Master text styles</a:t>
             </a:r>
           </a:p>
           <a:p>
             <a:pPr lvl="1"/>
             <a:r>
-              <a:rPr lang="en-US" smtClean="0"/>
+              <a:rPr lang="en-US"/>
               <a:t>Second level</a:t>
             </a:r>
           </a:p>
           <a:p>
             <a:pPr lvl="2"/>
             <a:r>
-              <a:rPr lang="en-US" smtClean="0"/>
+              <a:rPr lang="en-US"/>
               <a:t>Third level</a:t>
             </a:r>
           </a:p>
           <a:p>
             <a:pPr lvl="3"/>
             <a:r>
-              <a:rPr lang="en-US" smtClean="0"/>
+              <a:rPr lang="en-US"/>
               <a:t>Fourth level</a:t>
             </a:r>
           </a:p>
           <a:p>
             <a:pPr lvl="4"/>
             <a:r>
-              <a:rPr lang="en-US" smtClean="0"/>
+              <a:rPr lang="en-US"/>
               <a:t>Fifth level</a:t>
             </a:r>
-            <a:endParaRPr lang="en-US"/>
           </a:p>
         </p:txBody>
       </p:sp>
@@ -2725,9 +3320,9 @@
             </a:lvl1pPr>
           </a:lstStyle>
           <a:p>
-            <a:fld id="{5BCAD085-E8A6-8845-BD4E-CB4CCA059FC4}" type="datetimeFigureOut">
+            <a:fld id="{84F916B1-F069-4B57-8997-E8307208C489}" type="datetime1">
               <a:rPr lang="en-US" smtClean="0"/>
-              <a:t>1/27/13</a:t>
+              <a:t>9/5/2026</a:t>
             </a:fld>
             <a:endParaRPr lang="en-US"/>
           </a:p>
@@ -2766,7 +3361,10 @@
             </a:lvl1pPr>
           </a:lstStyle>
           <a:p>
-            <a:endParaRPr lang="en-US"/>
+            <a:r>
+              <a:rPr lang="en-US"/>
+              <a:t>ClosureCopilot · Mayuresh Piske · © 2026 Microsoft</a:t>
+            </a:r>
           </a:p>
         </p:txBody>
       </p:sp>
@@ -2832,6 +3430,7 @@
     <p:sldLayoutId id="2147483658" r:id="rId10"/>
     <p:sldLayoutId id="2147483659" r:id="rId11"/>
   </p:sldLayoutIdLst>
+  <p:hf hdr="0" dt="0"/>
   <p:txStyles>
     <p:titleStyle>
       <a:lvl1pPr algn="ctr" defTabSz="457200" rtl="0" eaLnBrk="1" latinLnBrk="0" hangingPunct="1">
@@ -3086,7 +3685,7 @@
 </file>
 
 <file path=ppt/slides/slide1.xml><?xml version="1.0" encoding="utf-8"?>
-<p:sld xmlns:a="http://schemas.openxmlformats.org/drawingml/2006/main" xmlns:p="http://schemas.openxmlformats.org/presentationml/2006/main" xmlns:r="http://schemas.openxmlformats.org/officeDocument/2006/relationships">
+<p:sld xmlns:a="http://schemas.openxmlformats.org/drawingml/2006/main" xmlns:r="http://schemas.openxmlformats.org/officeDocument/2006/relationships" xmlns:p="http://schemas.openxmlformats.org/presentationml/2006/main">
   <p:cSld>
     <p:spTree>
       <p:nvGrpSpPr>
@@ -3094,7 +3693,14 @@
         <p:cNvGrpSpPr/>
         <p:nvPr/>
       </p:nvGrpSpPr>
-      <p:grpSpPr/>
+      <p:grpSpPr>
+        <a:xfrm>
+          <a:off x="0" y="0"/>
+          <a:ext cx="0" cy="0"/>
+          <a:chOff x="0" y="0"/>
+          <a:chExt cx="0" cy="0"/>
+        </a:xfrm>
+      </p:grpSpPr>
       <p:sp>
         <p:nvSpPr>
           <p:cNvPr id="2" name="Rounded Rectangle 1"/>
@@ -3136,6 +3742,7 @@
           <a:lstStyle/>
           <a:p>
             <a:pPr algn="ctr"/>
+            <a:endParaRPr/>
           </a:p>
         </p:txBody>
       </p:sp>
@@ -3180,6 +3787,7 @@
           <a:lstStyle/>
           <a:p>
             <a:pPr algn="ctr"/>
+            <a:endParaRPr/>
           </a:p>
         </p:txBody>
       </p:sp>
@@ -3224,6 +3832,7 @@
           <a:lstStyle/>
           <a:p>
             <a:pPr algn="ctr"/>
+            <a:endParaRPr/>
           </a:p>
         </p:txBody>
       </p:sp>
@@ -3286,7 +3895,7 @@
           <a:p>
             <a:pPr algn="l"/>
             <a:r>
-              <a:rPr sz="2600" b="1">
+              <a:rPr sz="2600" b="1" dirty="0">
                 <a:solidFill>
                   <a:srgbClr val="BFD4F2"/>
                 </a:solidFill>
@@ -3321,7 +3930,7 @@
           <a:p>
             <a:pPr algn="l"/>
             <a:r>
-              <a:rPr sz="2000" b="0">
+              <a:rPr sz="2000" b="0" dirty="0">
                 <a:solidFill>
                   <a:srgbClr val="9FB8E0"/>
                 </a:solidFill>
@@ -3329,6 +3938,82 @@
               </a:rPr>
               <a:t>It decides WHERE each fix belongs — RTL  ·  SDC  ·  UPF</a:t>
             </a:r>
+          </a:p>
+        </p:txBody>
+      </p:sp>
+      <p:sp>
+        <p:nvSpPr>
+          <p:cNvPr id="11" name="TextBox 10">
+            <a:extLst>
+              <a:ext uri="{FF2B5EF4-FFF2-40B4-BE49-F238E27FC236}">
+                <a16:creationId xmlns:a16="http://schemas.microsoft.com/office/drawing/2014/main" id="{B25F93AE-AE4B-0369-7B8A-DF9D4A6D992F}"/>
+              </a:ext>
+            </a:extLst>
+          </p:cNvPr>
+          <p:cNvSpPr txBox="1"/>
+          <p:nvPr/>
+        </p:nvSpPr>
+        <p:spPr>
+          <a:xfrm>
+            <a:off x="868680" y="5501640"/>
+            <a:ext cx="10515600" cy="400110"/>
+          </a:xfrm>
+          <a:prstGeom prst="rect">
+            <a:avLst/>
+          </a:prstGeom>
+          <a:noFill/>
+        </p:spPr>
+        <p:txBody>
+          <a:bodyPr wrap="square" anchor="t">
+            <a:spAutoFit/>
+          </a:bodyPr>
+          <a:lstStyle/>
+          <a:p>
+            <a:pPr algn="l"/>
+            <a:r>
+              <a:rPr lang="en-IN" sz="2000" b="1" dirty="0">
+                <a:solidFill>
+                  <a:srgbClr val="BFD4F2"/>
+                </a:solidFill>
+                <a:latin typeface="Segoe UI"/>
+              </a:rPr>
+              <a:t>Mayuresh Piske</a:t>
+            </a:r>
+            <a:endParaRPr sz="2000" b="1" dirty="0">
+              <a:solidFill>
+                <a:srgbClr val="BFD4F2"/>
+              </a:solidFill>
+              <a:latin typeface="Segoe UI"/>
+            </a:endParaRPr>
+          </a:p>
+        </p:txBody>
+      </p:sp>
+      <p:sp>
+        <p:nvSpPr>
+          <p:cNvPr id="13" name="Slide Number Placeholder 12">
+            <a:extLst>
+              <a:ext uri="{FF2B5EF4-FFF2-40B4-BE49-F238E27FC236}">
+                <a16:creationId xmlns:a16="http://schemas.microsoft.com/office/drawing/2014/main" id="{AE762DB3-6B60-B04A-6D8B-ADDDF3DC6497}"/>
+              </a:ext>
+            </a:extLst>
+          </p:cNvPr>
+          <p:cNvSpPr>
+            <a:spLocks noGrp="1"/>
+          </p:cNvSpPr>
+          <p:nvPr>
+            <p:ph type="sldNum" sz="quarter" idx="12"/>
+          </p:nvPr>
+        </p:nvSpPr>
+        <p:spPr/>
+        <p:txBody>
+          <a:bodyPr/>
+          <a:lstStyle/>
+          <a:p>
+            <a:fld id="{C1FF6DA9-008F-8B48-92A6-B652298478BF}" type="slidenum">
+              <a:rPr lang="en-US" smtClean="0"/>
+              <a:t>1</a:t>
+            </a:fld>
+            <a:endParaRPr lang="en-US"/>
           </a:p>
         </p:txBody>
       </p:sp>
@@ -3341,7 +4026,7 @@
 </file>
 
 <file path=ppt/slides/slide2.xml><?xml version="1.0" encoding="utf-8"?>
-<p:sld xmlns:a="http://schemas.openxmlformats.org/drawingml/2006/main" xmlns:p="http://schemas.openxmlformats.org/presentationml/2006/main" xmlns:r="http://schemas.openxmlformats.org/officeDocument/2006/relationships">
+<p:sld xmlns:a="http://schemas.openxmlformats.org/drawingml/2006/main" xmlns:r="http://schemas.openxmlformats.org/officeDocument/2006/relationships" xmlns:p="http://schemas.openxmlformats.org/presentationml/2006/main">
   <p:cSld>
     <p:spTree>
       <p:nvGrpSpPr>
@@ -3349,51 +4034,14 @@
         <p:cNvGrpSpPr/>
         <p:nvPr/>
       </p:nvGrpSpPr>
-      <p:grpSpPr/>
-      <p:sp>
-        <p:nvSpPr>
-          <p:cNvPr id="2" name="Rounded Rectangle 1"/>
-          <p:cNvSpPr/>
-          <p:nvPr/>
-        </p:nvSpPr>
-        <p:spPr>
-          <a:xfrm>
-            <a:off x="0" y="0"/>
-            <a:ext cx="12191695" cy="6858000"/>
-          </a:xfrm>
-          <a:prstGeom prst="roundRect">
-            <a:avLst/>
-          </a:prstGeom>
-          <a:solidFill>
-            <a:srgbClr val="FFFFFF"/>
-          </a:solidFill>
-          <a:ln>
-            <a:noFill/>
-          </a:ln>
-          <a:effectLst/>
-        </p:spPr>
-        <p:style>
-          <a:lnRef idx="1">
-            <a:schemeClr val="accent1"/>
-          </a:lnRef>
-          <a:fillRef idx="3">
-            <a:schemeClr val="accent1"/>
-          </a:fillRef>
-          <a:effectRef idx="2">
-            <a:schemeClr val="accent1"/>
-          </a:effectRef>
-          <a:fontRef idx="minor">
-            <a:schemeClr val="lt1"/>
-          </a:fontRef>
-        </p:style>
-        <p:txBody>
-          <a:bodyPr rtlCol="0" anchor="ctr"/>
-          <a:lstStyle/>
-          <a:p>
-            <a:pPr algn="ctr"/>
-          </a:p>
-        </p:txBody>
-      </p:sp>
+      <p:grpSpPr>
+        <a:xfrm>
+          <a:off x="0" y="0"/>
+          <a:ext cx="0" cy="0"/>
+          <a:chOff x="0" y="0"/>
+          <a:chExt cx="0" cy="0"/>
+        </a:xfrm>
+      </p:grpSpPr>
       <p:sp>
         <p:nvSpPr>
           <p:cNvPr id="3" name="Rounded Rectangle 2"/>
@@ -3435,6 +4083,7 @@
           <a:lstStyle/>
           <a:p>
             <a:pPr algn="ctr"/>
+            <a:endParaRPr/>
           </a:p>
         </p:txBody>
       </p:sp>
@@ -3514,6 +4163,7 @@
           <a:lstStyle/>
           <a:p>
             <a:pPr algn="ctr"/>
+            <a:endParaRPr/>
           </a:p>
         </p:txBody>
       </p:sp>
@@ -3593,6 +4243,7 @@
           <a:lstStyle/>
           <a:p>
             <a:pPr algn="ctr"/>
+            <a:endParaRPr/>
           </a:p>
         </p:txBody>
       </p:sp>
@@ -3672,6 +4323,7 @@
           <a:lstStyle/>
           <a:p>
             <a:pPr algn="ctr"/>
+            <a:endParaRPr/>
           </a:p>
         </p:txBody>
       </p:sp>
@@ -3751,6 +4403,7 @@
           <a:lstStyle/>
           <a:p>
             <a:pPr algn="ctr"/>
+            <a:endParaRPr/>
           </a:p>
         </p:txBody>
       </p:sp>
@@ -3786,6 +4439,72 @@
               </a:rPr>
               <a:t>That expertise lives only in senior engineers' heads — and doesn't scale.</a:t>
             </a:r>
+          </a:p>
+        </p:txBody>
+      </p:sp>
+      <p:sp>
+        <p:nvSpPr>
+          <p:cNvPr id="13" name="Footer Placeholder 12">
+            <a:extLst>
+              <a:ext uri="{FF2B5EF4-FFF2-40B4-BE49-F238E27FC236}">
+                <a16:creationId xmlns:a16="http://schemas.microsoft.com/office/drawing/2014/main" id="{2CD06639-3C8E-33C0-FE69-B7ADA560992A}"/>
+              </a:ext>
+            </a:extLst>
+          </p:cNvPr>
+          <p:cNvSpPr>
+            <a:spLocks noGrp="1"/>
+          </p:cNvSpPr>
+          <p:nvPr>
+            <p:ph type="ftr" sz="quarter" idx="11"/>
+          </p:nvPr>
+        </p:nvSpPr>
+        <p:spPr>
+          <a:xfrm>
+            <a:off x="640080" y="6356350"/>
+            <a:ext cx="2653848" cy="365125"/>
+          </a:xfrm>
+        </p:spPr>
+        <p:txBody>
+          <a:bodyPr/>
+          <a:lstStyle/>
+          <a:p>
+            <a:r>
+              <a:rPr lang="en-US" dirty="0" err="1"/>
+              <a:t>ClosureCopilot</a:t>
+            </a:r>
+            <a:r>
+              <a:rPr lang="en-US" dirty="0"/>
+              <a:t> · © 2026 Microsoft</a:t>
+            </a:r>
+          </a:p>
+        </p:txBody>
+      </p:sp>
+      <p:sp>
+        <p:nvSpPr>
+          <p:cNvPr id="14" name="Slide Number Placeholder 13">
+            <a:extLst>
+              <a:ext uri="{FF2B5EF4-FFF2-40B4-BE49-F238E27FC236}">
+                <a16:creationId xmlns:a16="http://schemas.microsoft.com/office/drawing/2014/main" id="{58B4D48A-0156-D948-50BE-043CEEBF14D1}"/>
+              </a:ext>
+            </a:extLst>
+          </p:cNvPr>
+          <p:cNvSpPr>
+            <a:spLocks noGrp="1"/>
+          </p:cNvSpPr>
+          <p:nvPr>
+            <p:ph type="sldNum" sz="quarter" idx="12"/>
+          </p:nvPr>
+        </p:nvSpPr>
+        <p:spPr/>
+        <p:txBody>
+          <a:bodyPr/>
+          <a:lstStyle/>
+          <a:p>
+            <a:fld id="{C1FF6DA9-008F-8B48-92A6-B652298478BF}" type="slidenum">
+              <a:rPr lang="en-US" smtClean="0"/>
+              <a:t>2</a:t>
+            </a:fld>
+            <a:endParaRPr lang="en-US"/>
           </a:p>
         </p:txBody>
       </p:sp>
@@ -3798,7 +4517,7 @@
 </file>
 
 <file path=ppt/slides/slide3.xml><?xml version="1.0" encoding="utf-8"?>
-<p:sld xmlns:a="http://schemas.openxmlformats.org/drawingml/2006/main" xmlns:p="http://schemas.openxmlformats.org/presentationml/2006/main" xmlns:r="http://schemas.openxmlformats.org/officeDocument/2006/relationships">
+<p:sld xmlns:a="http://schemas.openxmlformats.org/drawingml/2006/main" xmlns:r="http://schemas.openxmlformats.org/officeDocument/2006/relationships" xmlns:p="http://schemas.openxmlformats.org/presentationml/2006/main">
   <p:cSld>
     <p:spTree>
       <p:nvGrpSpPr>
@@ -3806,7 +4525,14 @@
         <p:cNvGrpSpPr/>
         <p:nvPr/>
       </p:nvGrpSpPr>
-      <p:grpSpPr/>
+      <p:grpSpPr>
+        <a:xfrm>
+          <a:off x="0" y="0"/>
+          <a:ext cx="0" cy="0"/>
+          <a:chOff x="0" y="0"/>
+          <a:chExt cx="0" cy="0"/>
+        </a:xfrm>
+      </p:grpSpPr>
       <p:sp>
         <p:nvSpPr>
           <p:cNvPr id="2" name="Rounded Rectangle 1"/>
@@ -3848,6 +4574,7 @@
           <a:lstStyle/>
           <a:p>
             <a:pPr algn="ctr"/>
+            <a:endParaRPr/>
           </a:p>
         </p:txBody>
       </p:sp>
@@ -3892,6 +4619,7 @@
           <a:lstStyle/>
           <a:p>
             <a:pPr algn="ctr"/>
+            <a:endParaRPr/>
           </a:p>
         </p:txBody>
       </p:sp>
@@ -3903,8 +4631,8 @@
         </p:nvSpPr>
         <p:spPr>
           <a:xfrm>
-            <a:off x="548640" y="164592"/>
-            <a:ext cx="10972800" cy="731520"/>
+            <a:off x="548640" y="253353"/>
+            <a:ext cx="10972800" cy="553998"/>
           </a:xfrm>
           <a:prstGeom prst="rect">
             <a:avLst/>
@@ -3918,6 +4646,24 @@
           <a:lstStyle/>
           <a:p>
             <a:pPr algn="l"/>
+            <a:r>
+              <a:rPr sz="3000" b="1" dirty="0">
+                <a:solidFill>
+                  <a:srgbClr val="FFFFFF"/>
+                </a:solidFill>
+                <a:latin typeface="Segoe UI"/>
+              </a:rPr>
+              <a:t>One copilot · </a:t>
+            </a:r>
+            <a:r>
+              <a:rPr lang="en-IN" sz="3000" b="1">
+                <a:solidFill>
+                  <a:srgbClr val="FFFFFF"/>
+                </a:solidFill>
+                <a:latin typeface="Segoe UI"/>
+              </a:rPr>
+              <a:t>multi</a:t>
+            </a:r>
             <a:r>
               <a:rPr sz="3000" b="1">
                 <a:solidFill>
@@ -3925,7 +4671,7 @@
                 </a:solidFill>
                 <a:latin typeface="Segoe UI"/>
               </a:rPr>
-              <a:t>One copilot · 9 agents · any backend report</a:t>
+              <a:t> agents · any backend report</a:t>
             </a:r>
           </a:p>
         </p:txBody>
@@ -3946,8 +4692,8 @@
         </p:blipFill>
         <p:spPr>
           <a:xfrm>
-            <a:off x="1097280" y="1234440"/>
-            <a:ext cx="10058400" cy="7133727"/>
+            <a:off x="2104371" y="1060704"/>
+            <a:ext cx="7511205" cy="5327178"/>
           </a:xfrm>
           <a:prstGeom prst="rect">
             <a:avLst/>
@@ -3986,6 +4732,72 @@
               </a:rPr>
               <a:t>Tool-agnostic parsers normalize STA · synthesis · power · area · UPF · SDC · congestion into one finding model.</a:t>
             </a:r>
+          </a:p>
+        </p:txBody>
+      </p:sp>
+      <p:sp>
+        <p:nvSpPr>
+          <p:cNvPr id="7" name="Footer Placeholder 6">
+            <a:extLst>
+              <a:ext uri="{FF2B5EF4-FFF2-40B4-BE49-F238E27FC236}">
+                <a16:creationId xmlns:a16="http://schemas.microsoft.com/office/drawing/2014/main" id="{70C64B5F-0A6D-53D4-7F8E-684E630ACE64}"/>
+              </a:ext>
+            </a:extLst>
+          </p:cNvPr>
+          <p:cNvSpPr>
+            <a:spLocks noGrp="1"/>
+          </p:cNvSpPr>
+          <p:nvPr>
+            <p:ph type="ftr" sz="quarter" idx="11"/>
+          </p:nvPr>
+        </p:nvSpPr>
+        <p:spPr>
+          <a:xfrm>
+            <a:off x="548639" y="6476792"/>
+            <a:ext cx="2564987" cy="365125"/>
+          </a:xfrm>
+        </p:spPr>
+        <p:txBody>
+          <a:bodyPr/>
+          <a:lstStyle/>
+          <a:p>
+            <a:r>
+              <a:rPr lang="en-US" dirty="0" err="1"/>
+              <a:t>ClosureCopilot</a:t>
+            </a:r>
+            <a:r>
+              <a:rPr lang="en-US" dirty="0"/>
+              <a:t> · © 2026 Microsoft</a:t>
+            </a:r>
+          </a:p>
+        </p:txBody>
+      </p:sp>
+      <p:sp>
+        <p:nvSpPr>
+          <p:cNvPr id="8" name="Slide Number Placeholder 7">
+            <a:extLst>
+              <a:ext uri="{FF2B5EF4-FFF2-40B4-BE49-F238E27FC236}">
+                <a16:creationId xmlns:a16="http://schemas.microsoft.com/office/drawing/2014/main" id="{B32A82C9-93A7-3E31-8886-F5057491504C}"/>
+              </a:ext>
+            </a:extLst>
+          </p:cNvPr>
+          <p:cNvSpPr>
+            <a:spLocks noGrp="1"/>
+          </p:cNvSpPr>
+          <p:nvPr>
+            <p:ph type="sldNum" sz="quarter" idx="12"/>
+          </p:nvPr>
+        </p:nvSpPr>
+        <p:spPr/>
+        <p:txBody>
+          <a:bodyPr/>
+          <a:lstStyle/>
+          <a:p>
+            <a:fld id="{C1FF6DA9-008F-8B48-92A6-B652298478BF}" type="slidenum">
+              <a:rPr lang="en-US" smtClean="0"/>
+              <a:t>3</a:t>
+            </a:fld>
+            <a:endParaRPr lang="en-US"/>
           </a:p>
         </p:txBody>
       </p:sp>
@@ -3998,7 +4810,7 @@
 </file>
 
 <file path=ppt/slides/slide4.xml><?xml version="1.0" encoding="utf-8"?>
-<p:sld xmlns:a="http://schemas.openxmlformats.org/drawingml/2006/main" xmlns:p="http://schemas.openxmlformats.org/presentationml/2006/main" xmlns:r="http://schemas.openxmlformats.org/officeDocument/2006/relationships">
+<p:sld xmlns:a="http://schemas.openxmlformats.org/drawingml/2006/main" xmlns:r="http://schemas.openxmlformats.org/officeDocument/2006/relationships" xmlns:p="http://schemas.openxmlformats.org/presentationml/2006/main">
   <p:cSld>
     <p:spTree>
       <p:nvGrpSpPr>
@@ -4006,7 +4818,14 @@
         <p:cNvGrpSpPr/>
         <p:nvPr/>
       </p:nvGrpSpPr>
-      <p:grpSpPr/>
+      <p:grpSpPr>
+        <a:xfrm>
+          <a:off x="0" y="0"/>
+          <a:ext cx="0" cy="0"/>
+          <a:chOff x="0" y="0"/>
+          <a:chExt cx="0" cy="0"/>
+        </a:xfrm>
+      </p:grpSpPr>
       <p:sp>
         <p:nvSpPr>
           <p:cNvPr id="2" name="Rounded Rectangle 1"/>
@@ -4048,6 +4867,7 @@
           <a:lstStyle/>
           <a:p>
             <a:pPr algn="ctr"/>
+            <a:endParaRPr/>
           </a:p>
         </p:txBody>
       </p:sp>
@@ -4092,6 +4912,7 @@
           <a:lstStyle/>
           <a:p>
             <a:pPr algn="ctr"/>
+            <a:endParaRPr/>
           </a:p>
         </p:txBody>
       </p:sp>
@@ -4206,6 +5027,7 @@
           <a:lstStyle/>
           <a:p>
             <a:pPr algn="ctr"/>
+            <a:endParaRPr/>
           </a:p>
         </p:txBody>
       </p:sp>
@@ -4321,6 +5143,7 @@
           <a:lstStyle/>
           <a:p>
             <a:pPr algn="ctr"/>
+            <a:endParaRPr/>
           </a:p>
         </p:txBody>
       </p:sp>
@@ -4427,6 +5250,72 @@
               </a:rPr>
               <a:t>Every fix ships with a corrected, copy-paste snippet + a cross-domain PPA trade-off.</a:t>
             </a:r>
+          </a:p>
+        </p:txBody>
+      </p:sp>
+      <p:sp>
+        <p:nvSpPr>
+          <p:cNvPr id="11" name="Footer Placeholder 10">
+            <a:extLst>
+              <a:ext uri="{FF2B5EF4-FFF2-40B4-BE49-F238E27FC236}">
+                <a16:creationId xmlns:a16="http://schemas.microsoft.com/office/drawing/2014/main" id="{CDCA28F5-24ED-C6C5-22BD-9A93D513A93A}"/>
+              </a:ext>
+            </a:extLst>
+          </p:cNvPr>
+          <p:cNvSpPr>
+            <a:spLocks noGrp="1"/>
+          </p:cNvSpPr>
+          <p:nvPr>
+            <p:ph type="ftr" sz="quarter" idx="11"/>
+          </p:nvPr>
+        </p:nvSpPr>
+        <p:spPr>
+          <a:xfrm>
+            <a:off x="640080" y="6424613"/>
+            <a:ext cx="3639855" cy="365125"/>
+          </a:xfrm>
+        </p:spPr>
+        <p:txBody>
+          <a:bodyPr/>
+          <a:lstStyle/>
+          <a:p>
+            <a:r>
+              <a:rPr lang="en-US" dirty="0" err="1"/>
+              <a:t>ClosureCopilot</a:t>
+            </a:r>
+            <a:r>
+              <a:rPr lang="en-US" dirty="0"/>
+              <a:t> · Mayuresh Piske · © 2026 Microsoft</a:t>
+            </a:r>
+          </a:p>
+        </p:txBody>
+      </p:sp>
+      <p:sp>
+        <p:nvSpPr>
+          <p:cNvPr id="12" name="Slide Number Placeholder 11">
+            <a:extLst>
+              <a:ext uri="{FF2B5EF4-FFF2-40B4-BE49-F238E27FC236}">
+                <a16:creationId xmlns:a16="http://schemas.microsoft.com/office/drawing/2014/main" id="{F984C18B-1FB8-7174-D3B2-FEBB893456F6}"/>
+              </a:ext>
+            </a:extLst>
+          </p:cNvPr>
+          <p:cNvSpPr>
+            <a:spLocks noGrp="1"/>
+          </p:cNvSpPr>
+          <p:nvPr>
+            <p:ph type="sldNum" sz="quarter" idx="12"/>
+          </p:nvPr>
+        </p:nvSpPr>
+        <p:spPr/>
+        <p:txBody>
+          <a:bodyPr/>
+          <a:lstStyle/>
+          <a:p>
+            <a:fld id="{C1FF6DA9-008F-8B48-92A6-B652298478BF}" type="slidenum">
+              <a:rPr lang="en-US" smtClean="0"/>
+              <a:t>4</a:t>
+            </a:fld>
+            <a:endParaRPr lang="en-US"/>
           </a:p>
         </p:txBody>
       </p:sp>
@@ -4439,7 +5328,7 @@
 </file>
 
 <file path=ppt/slides/slide5.xml><?xml version="1.0" encoding="utf-8"?>
-<p:sld xmlns:a="http://schemas.openxmlformats.org/drawingml/2006/main" xmlns:p="http://schemas.openxmlformats.org/presentationml/2006/main" xmlns:r="http://schemas.openxmlformats.org/officeDocument/2006/relationships">
+<p:sld xmlns:a="http://schemas.openxmlformats.org/drawingml/2006/main" xmlns:r="http://schemas.openxmlformats.org/officeDocument/2006/relationships" xmlns:p="http://schemas.openxmlformats.org/presentationml/2006/main">
   <p:cSld>
     <p:spTree>
       <p:nvGrpSpPr>
@@ -4447,7 +5336,14 @@
         <p:cNvGrpSpPr/>
         <p:nvPr/>
       </p:nvGrpSpPr>
-      <p:grpSpPr/>
+      <p:grpSpPr>
+        <a:xfrm>
+          <a:off x="0" y="0"/>
+          <a:ext cx="0" cy="0"/>
+          <a:chOff x="0" y="0"/>
+          <a:chExt cx="0" cy="0"/>
+        </a:xfrm>
+      </p:grpSpPr>
       <p:sp>
         <p:nvSpPr>
           <p:cNvPr id="2" name="Rounded Rectangle 1"/>
@@ -4489,6 +5385,7 @@
           <a:lstStyle/>
           <a:p>
             <a:pPr algn="ctr"/>
+            <a:endParaRPr/>
           </a:p>
         </p:txBody>
       </p:sp>
@@ -4533,6 +5430,7 @@
           <a:lstStyle/>
           <a:p>
             <a:pPr algn="ctr"/>
+            <a:endParaRPr/>
           </a:p>
         </p:txBody>
       </p:sp>
@@ -4612,6 +5510,7 @@
           <a:lstStyle/>
           <a:p>
             <a:pPr algn="ctr"/>
+            <a:endParaRPr/>
           </a:p>
         </p:txBody>
       </p:sp>
@@ -4656,6 +5555,7 @@
           <a:lstStyle/>
           <a:p>
             <a:pPr algn="ctr"/>
+            <a:endParaRPr/>
           </a:p>
         </p:txBody>
       </p:sp>
@@ -4770,6 +5670,7 @@
           <a:lstStyle/>
           <a:p>
             <a:pPr algn="ctr"/>
+            <a:endParaRPr/>
           </a:p>
         </p:txBody>
       </p:sp>
@@ -4814,6 +5715,7 @@
           <a:lstStyle/>
           <a:p>
             <a:pPr algn="ctr"/>
+            <a:endParaRPr/>
           </a:p>
         </p:txBody>
       </p:sp>
@@ -4928,6 +5830,7 @@
           <a:lstStyle/>
           <a:p>
             <a:pPr algn="ctr"/>
+            <a:endParaRPr/>
           </a:p>
         </p:txBody>
       </p:sp>
@@ -4972,6 +5875,7 @@
           <a:lstStyle/>
           <a:p>
             <a:pPr algn="ctr"/>
+            <a:endParaRPr/>
           </a:p>
         </p:txBody>
       </p:sp>
@@ -5086,6 +5990,7 @@
           <a:lstStyle/>
           <a:p>
             <a:pPr algn="ctr"/>
+            <a:endParaRPr/>
           </a:p>
         </p:txBody>
       </p:sp>
@@ -5130,6 +6035,7 @@
           <a:lstStyle/>
           <a:p>
             <a:pPr algn="ctr"/>
+            <a:endParaRPr/>
           </a:p>
         </p:txBody>
       </p:sp>
@@ -5244,6 +6150,7 @@
           <a:lstStyle/>
           <a:p>
             <a:pPr algn="ctr"/>
+            <a:endParaRPr/>
           </a:p>
         </p:txBody>
       </p:sp>
@@ -5288,6 +6195,7 @@
           <a:lstStyle/>
           <a:p>
             <a:pPr algn="ctr"/>
+            <a:endParaRPr/>
           </a:p>
         </p:txBody>
       </p:sp>
@@ -5358,6 +6266,72 @@
               </a:rPr>
               <a:t>Turns P&amp;R congestion into concrete RTL restructuring hints.</a:t>
             </a:r>
+          </a:p>
+        </p:txBody>
+      </p:sp>
+      <p:sp>
+        <p:nvSpPr>
+          <p:cNvPr id="25" name="Footer Placeholder 24">
+            <a:extLst>
+              <a:ext uri="{FF2B5EF4-FFF2-40B4-BE49-F238E27FC236}">
+                <a16:creationId xmlns:a16="http://schemas.microsoft.com/office/drawing/2014/main" id="{7E55F50A-2D07-CDDF-D02C-81095889BAF9}"/>
+              </a:ext>
+            </a:extLst>
+          </p:cNvPr>
+          <p:cNvSpPr>
+            <a:spLocks noGrp="1"/>
+          </p:cNvSpPr>
+          <p:nvPr>
+            <p:ph type="ftr" sz="quarter" idx="11"/>
+          </p:nvPr>
+        </p:nvSpPr>
+        <p:spPr>
+          <a:xfrm>
+            <a:off x="722376" y="6492875"/>
+            <a:ext cx="3483279" cy="365125"/>
+          </a:xfrm>
+        </p:spPr>
+        <p:txBody>
+          <a:bodyPr/>
+          <a:lstStyle/>
+          <a:p>
+            <a:r>
+              <a:rPr lang="en-US" dirty="0" err="1"/>
+              <a:t>ClosureCopilot</a:t>
+            </a:r>
+            <a:r>
+              <a:rPr lang="en-US" dirty="0"/>
+              <a:t> · Mayuresh Piske · © 2026 Microsoft</a:t>
+            </a:r>
+          </a:p>
+        </p:txBody>
+      </p:sp>
+      <p:sp>
+        <p:nvSpPr>
+          <p:cNvPr id="26" name="Slide Number Placeholder 25">
+            <a:extLst>
+              <a:ext uri="{FF2B5EF4-FFF2-40B4-BE49-F238E27FC236}">
+                <a16:creationId xmlns:a16="http://schemas.microsoft.com/office/drawing/2014/main" id="{97A18FC6-935B-46D4-22CB-3431383DA313}"/>
+              </a:ext>
+            </a:extLst>
+          </p:cNvPr>
+          <p:cNvSpPr>
+            <a:spLocks noGrp="1"/>
+          </p:cNvSpPr>
+          <p:nvPr>
+            <p:ph type="sldNum" sz="quarter" idx="12"/>
+          </p:nvPr>
+        </p:nvSpPr>
+        <p:spPr/>
+        <p:txBody>
+          <a:bodyPr/>
+          <a:lstStyle/>
+          <a:p>
+            <a:fld id="{C1FF6DA9-008F-8B48-92A6-B652298478BF}" type="slidenum">
+              <a:rPr lang="en-US" smtClean="0"/>
+              <a:t>5</a:t>
+            </a:fld>
+            <a:endParaRPr lang="en-US"/>
           </a:p>
         </p:txBody>
       </p:sp>
@@ -5370,7 +6344,7 @@
 </file>
 
 <file path=ppt/slides/slide6.xml><?xml version="1.0" encoding="utf-8"?>
-<p:sld xmlns:a="http://schemas.openxmlformats.org/drawingml/2006/main" xmlns:p="http://schemas.openxmlformats.org/presentationml/2006/main" xmlns:r="http://schemas.openxmlformats.org/officeDocument/2006/relationships">
+<p:sld xmlns:a="http://schemas.openxmlformats.org/drawingml/2006/main" xmlns:r="http://schemas.openxmlformats.org/officeDocument/2006/relationships" xmlns:p="http://schemas.openxmlformats.org/presentationml/2006/main">
   <p:cSld>
     <p:spTree>
       <p:nvGrpSpPr>
@@ -5378,7 +6352,14 @@
         <p:cNvGrpSpPr/>
         <p:nvPr/>
       </p:nvGrpSpPr>
-      <p:grpSpPr/>
+      <p:grpSpPr>
+        <a:xfrm>
+          <a:off x="0" y="0"/>
+          <a:ext cx="0" cy="0"/>
+          <a:chOff x="0" y="0"/>
+          <a:chExt cx="0" cy="0"/>
+        </a:xfrm>
+      </p:grpSpPr>
       <p:sp>
         <p:nvSpPr>
           <p:cNvPr id="2" name="Rounded Rectangle 1"/>
@@ -5420,6 +6401,7 @@
           <a:lstStyle/>
           <a:p>
             <a:pPr algn="ctr"/>
+            <a:endParaRPr/>
           </a:p>
         </p:txBody>
       </p:sp>
@@ -5464,6 +6446,7 @@
           <a:lstStyle/>
           <a:p>
             <a:pPr algn="ctr"/>
+            <a:endParaRPr/>
           </a:p>
         </p:txBody>
       </p:sp>
@@ -5543,6 +6526,7 @@
           <a:lstStyle/>
           <a:p>
             <a:pPr algn="ctr"/>
+            <a:endParaRPr/>
           </a:p>
         </p:txBody>
       </p:sp>
@@ -5682,6 +6666,7 @@
           <a:lstStyle/>
           <a:p>
             <a:pPr algn="ctr"/>
+            <a:endParaRPr/>
           </a:p>
         </p:txBody>
       </p:sp>
@@ -5777,6 +6762,72 @@
               </a:rPr>
               <a:t>Runs reliably with or without credentials — the demo never breaks.</a:t>
             </a:r>
+          </a:p>
+        </p:txBody>
+      </p:sp>
+      <p:sp>
+        <p:nvSpPr>
+          <p:cNvPr id="9" name="Footer Placeholder 8">
+            <a:extLst>
+              <a:ext uri="{FF2B5EF4-FFF2-40B4-BE49-F238E27FC236}">
+                <a16:creationId xmlns:a16="http://schemas.microsoft.com/office/drawing/2014/main" id="{FB081541-3697-02EB-CA09-947B1D5C7B05}"/>
+              </a:ext>
+            </a:extLst>
+          </p:cNvPr>
+          <p:cNvSpPr>
+            <a:spLocks noGrp="1"/>
+          </p:cNvSpPr>
+          <p:nvPr>
+            <p:ph type="ftr" sz="quarter" idx="11"/>
+          </p:nvPr>
+        </p:nvSpPr>
+        <p:spPr>
+          <a:xfrm>
+            <a:off x="726509" y="6463461"/>
+            <a:ext cx="3721274" cy="365125"/>
+          </a:xfrm>
+        </p:spPr>
+        <p:txBody>
+          <a:bodyPr/>
+          <a:lstStyle/>
+          <a:p>
+            <a:r>
+              <a:rPr lang="en-US" dirty="0" err="1"/>
+              <a:t>ClosureCopilot</a:t>
+            </a:r>
+            <a:r>
+              <a:rPr lang="en-US" dirty="0"/>
+              <a:t> · Mayuresh Piske · © 2026 Microsoft</a:t>
+            </a:r>
+          </a:p>
+        </p:txBody>
+      </p:sp>
+      <p:sp>
+        <p:nvSpPr>
+          <p:cNvPr id="10" name="Slide Number Placeholder 9">
+            <a:extLst>
+              <a:ext uri="{FF2B5EF4-FFF2-40B4-BE49-F238E27FC236}">
+                <a16:creationId xmlns:a16="http://schemas.microsoft.com/office/drawing/2014/main" id="{3D4ED3BB-8D92-13D8-AB29-2BD15A55CE06}"/>
+              </a:ext>
+            </a:extLst>
+          </p:cNvPr>
+          <p:cNvSpPr>
+            <a:spLocks noGrp="1"/>
+          </p:cNvSpPr>
+          <p:nvPr>
+            <p:ph type="sldNum" sz="quarter" idx="12"/>
+          </p:nvPr>
+        </p:nvSpPr>
+        <p:spPr/>
+        <p:txBody>
+          <a:bodyPr/>
+          <a:lstStyle/>
+          <a:p>
+            <a:fld id="{C1FF6DA9-008F-8B48-92A6-B652298478BF}" type="slidenum">
+              <a:rPr lang="en-US" smtClean="0"/>
+              <a:t>6</a:t>
+            </a:fld>
+            <a:endParaRPr lang="en-US"/>
           </a:p>
         </p:txBody>
       </p:sp>
@@ -5789,7 +6840,7 @@
 </file>
 
 <file path=ppt/slides/slide7.xml><?xml version="1.0" encoding="utf-8"?>
-<p:sld xmlns:a="http://schemas.openxmlformats.org/drawingml/2006/main" xmlns:p="http://schemas.openxmlformats.org/presentationml/2006/main" xmlns:r="http://schemas.openxmlformats.org/officeDocument/2006/relationships">
+<p:sld xmlns:a="http://schemas.openxmlformats.org/drawingml/2006/main" xmlns:r="http://schemas.openxmlformats.org/officeDocument/2006/relationships" xmlns:p="http://schemas.openxmlformats.org/presentationml/2006/main">
   <p:cSld>
     <p:spTree>
       <p:nvGrpSpPr>
@@ -5797,7 +6848,14 @@
         <p:cNvGrpSpPr/>
         <p:nvPr/>
       </p:nvGrpSpPr>
-      <p:grpSpPr/>
+      <p:grpSpPr>
+        <a:xfrm>
+          <a:off x="0" y="0"/>
+          <a:ext cx="0" cy="0"/>
+          <a:chOff x="0" y="0"/>
+          <a:chExt cx="0" cy="0"/>
+        </a:xfrm>
+      </p:grpSpPr>
       <p:sp>
         <p:nvSpPr>
           <p:cNvPr id="2" name="Rounded Rectangle 1"/>
@@ -5839,6 +6897,7 @@
           <a:lstStyle/>
           <a:p>
             <a:pPr algn="ctr"/>
+            <a:endParaRPr/>
           </a:p>
         </p:txBody>
       </p:sp>
@@ -5883,6 +6942,7 @@
           <a:lstStyle/>
           <a:p>
             <a:pPr algn="ctr"/>
+            <a:endParaRPr/>
           </a:p>
         </p:txBody>
       </p:sp>
@@ -5962,6 +7022,7 @@
           <a:lstStyle/>
           <a:p>
             <a:pPr algn="ctr"/>
+            <a:endParaRPr/>
           </a:p>
         </p:txBody>
       </p:sp>
@@ -6065,6 +7126,7 @@
           <a:lstStyle/>
           <a:p>
             <a:pPr algn="ctr"/>
+            <a:endParaRPr/>
           </a:p>
         </p:txBody>
       </p:sp>
@@ -6136,6 +7198,72 @@
               </a:rPr>
               <a:t>Catches unrealized intent and lost constraints before the next costly backend run.</a:t>
             </a:r>
+          </a:p>
+        </p:txBody>
+      </p:sp>
+      <p:sp>
+        <p:nvSpPr>
+          <p:cNvPr id="9" name="Footer Placeholder 8">
+            <a:extLst>
+              <a:ext uri="{FF2B5EF4-FFF2-40B4-BE49-F238E27FC236}">
+                <a16:creationId xmlns:a16="http://schemas.microsoft.com/office/drawing/2014/main" id="{3F30E14D-839F-E276-DF2D-B2EF76D28596}"/>
+              </a:ext>
+            </a:extLst>
+          </p:cNvPr>
+          <p:cNvSpPr>
+            <a:spLocks noGrp="1"/>
+          </p:cNvSpPr>
+          <p:nvPr>
+            <p:ph type="ftr" sz="quarter" idx="11"/>
+          </p:nvPr>
+        </p:nvSpPr>
+        <p:spPr>
+          <a:xfrm>
+            <a:off x="640080" y="6440601"/>
+            <a:ext cx="3821482" cy="365125"/>
+          </a:xfrm>
+        </p:spPr>
+        <p:txBody>
+          <a:bodyPr/>
+          <a:lstStyle/>
+          <a:p>
+            <a:r>
+              <a:rPr lang="en-US" dirty="0" err="1"/>
+              <a:t>ClosureCopilot</a:t>
+            </a:r>
+            <a:r>
+              <a:rPr lang="en-US" dirty="0"/>
+              <a:t> · Mayuresh Piske · © 2026 Microsoft</a:t>
+            </a:r>
+          </a:p>
+        </p:txBody>
+      </p:sp>
+      <p:sp>
+        <p:nvSpPr>
+          <p:cNvPr id="10" name="Slide Number Placeholder 9">
+            <a:extLst>
+              <a:ext uri="{FF2B5EF4-FFF2-40B4-BE49-F238E27FC236}">
+                <a16:creationId xmlns:a16="http://schemas.microsoft.com/office/drawing/2014/main" id="{6BCC1590-4137-BEAB-B5DE-8490219A9C3C}"/>
+              </a:ext>
+            </a:extLst>
+          </p:cNvPr>
+          <p:cNvSpPr>
+            <a:spLocks noGrp="1"/>
+          </p:cNvSpPr>
+          <p:nvPr>
+            <p:ph type="sldNum" sz="quarter" idx="12"/>
+          </p:nvPr>
+        </p:nvSpPr>
+        <p:spPr/>
+        <p:txBody>
+          <a:bodyPr/>
+          <a:lstStyle/>
+          <a:p>
+            <a:fld id="{C1FF6DA9-008F-8B48-92A6-B652298478BF}" type="slidenum">
+              <a:rPr lang="en-US" smtClean="0"/>
+              <a:t>7</a:t>
+            </a:fld>
+            <a:endParaRPr lang="en-US"/>
           </a:p>
         </p:txBody>
       </p:sp>
@@ -6148,7 +7276,7 @@
 </file>
 
 <file path=ppt/slides/slide8.xml><?xml version="1.0" encoding="utf-8"?>
-<p:sld xmlns:a="http://schemas.openxmlformats.org/drawingml/2006/main" xmlns:p="http://schemas.openxmlformats.org/presentationml/2006/main" xmlns:r="http://schemas.openxmlformats.org/officeDocument/2006/relationships">
+<p:sld xmlns:a="http://schemas.openxmlformats.org/drawingml/2006/main" xmlns:r="http://schemas.openxmlformats.org/officeDocument/2006/relationships" xmlns:p="http://schemas.openxmlformats.org/presentationml/2006/main">
   <p:cSld>
     <p:spTree>
       <p:nvGrpSpPr>
@@ -6156,7 +7284,14 @@
         <p:cNvGrpSpPr/>
         <p:nvPr/>
       </p:nvGrpSpPr>
-      <p:grpSpPr/>
+      <p:grpSpPr>
+        <a:xfrm>
+          <a:off x="0" y="0"/>
+          <a:ext cx="0" cy="0"/>
+          <a:chOff x="0" y="0"/>
+          <a:chExt cx="0" cy="0"/>
+        </a:xfrm>
+      </p:grpSpPr>
       <p:sp>
         <p:nvSpPr>
           <p:cNvPr id="2" name="Rounded Rectangle 1"/>
@@ -6198,6 +7333,7 @@
           <a:lstStyle/>
           <a:p>
             <a:pPr algn="ctr"/>
+            <a:endParaRPr/>
           </a:p>
         </p:txBody>
       </p:sp>
@@ -6303,6 +7439,72 @@
               </a:rPr>
               <a:t>github.com/mayureshpiske19/ClosureCopilot</a:t>
             </a:r>
+          </a:p>
+        </p:txBody>
+      </p:sp>
+      <p:sp>
+        <p:nvSpPr>
+          <p:cNvPr id="6" name="Footer Placeholder 5">
+            <a:extLst>
+              <a:ext uri="{FF2B5EF4-FFF2-40B4-BE49-F238E27FC236}">
+                <a16:creationId xmlns:a16="http://schemas.microsoft.com/office/drawing/2014/main" id="{C4C2C17A-6560-086A-57BE-9E6D36D66ACA}"/>
+              </a:ext>
+            </a:extLst>
+          </p:cNvPr>
+          <p:cNvSpPr>
+            <a:spLocks noGrp="1"/>
+          </p:cNvSpPr>
+          <p:nvPr>
+            <p:ph type="ftr" sz="quarter" idx="11"/>
+          </p:nvPr>
+        </p:nvSpPr>
+        <p:spPr>
+          <a:xfrm>
+            <a:off x="822960" y="6356350"/>
+            <a:ext cx="4072003" cy="365125"/>
+          </a:xfrm>
+        </p:spPr>
+        <p:txBody>
+          <a:bodyPr/>
+          <a:lstStyle/>
+          <a:p>
+            <a:r>
+              <a:rPr lang="en-US" dirty="0" err="1"/>
+              <a:t>ClosureCopilot</a:t>
+            </a:r>
+            <a:r>
+              <a:rPr lang="en-US" dirty="0"/>
+              <a:t> · Mayuresh Piske · © 2026 Microsoft</a:t>
+            </a:r>
+          </a:p>
+        </p:txBody>
+      </p:sp>
+      <p:sp>
+        <p:nvSpPr>
+          <p:cNvPr id="7" name="Slide Number Placeholder 6">
+            <a:extLst>
+              <a:ext uri="{FF2B5EF4-FFF2-40B4-BE49-F238E27FC236}">
+                <a16:creationId xmlns:a16="http://schemas.microsoft.com/office/drawing/2014/main" id="{4B62701B-EC8F-97EC-DB7F-0A1AFE4EFE25}"/>
+              </a:ext>
+            </a:extLst>
+          </p:cNvPr>
+          <p:cNvSpPr>
+            <a:spLocks noGrp="1"/>
+          </p:cNvSpPr>
+          <p:nvPr>
+            <p:ph type="sldNum" sz="quarter" idx="12"/>
+          </p:nvPr>
+        </p:nvSpPr>
+        <p:spPr/>
+        <p:txBody>
+          <a:bodyPr/>
+          <a:lstStyle/>
+          <a:p>
+            <a:fld id="{C1FF6DA9-008F-8B48-92A6-B652298478BF}" type="slidenum">
+              <a:rPr lang="en-US" smtClean="0"/>
+              <a:t>8</a:t>
+            </a:fld>
+            <a:endParaRPr lang="en-US"/>
           </a:p>
         </p:txBody>
       </p:sp>
@@ -6632,4 +7834,325 @@
   </a:objectDefaults>
   <a:extraClrSchemeLst/>
 </a:theme>
+</file>
+
+<file path=ppt/theme/theme2.xml><?xml version="1.0" encoding="utf-8"?>
+<a:theme xmlns:a="http://schemas.openxmlformats.org/drawingml/2006/main" name="Office Theme">
+  <a:themeElements>
+    <a:clrScheme name="Office">
+      <a:dk1>
+        <a:sysClr val="windowText" lastClr="000000"/>
+      </a:dk1>
+      <a:lt1>
+        <a:sysClr val="window" lastClr="FFFFFF"/>
+      </a:lt1>
+      <a:dk2>
+        <a:srgbClr val="0E2841"/>
+      </a:dk2>
+      <a:lt2>
+        <a:srgbClr val="E8E8E8"/>
+      </a:lt2>
+      <a:accent1>
+        <a:srgbClr val="156082"/>
+      </a:accent1>
+      <a:accent2>
+        <a:srgbClr val="E97132"/>
+      </a:accent2>
+      <a:accent3>
+        <a:srgbClr val="196B24"/>
+      </a:accent3>
+      <a:accent4>
+        <a:srgbClr val="0F9ED5"/>
+      </a:accent4>
+      <a:accent5>
+        <a:srgbClr val="A02B93"/>
+      </a:accent5>
+      <a:accent6>
+        <a:srgbClr val="4EA72E"/>
+      </a:accent6>
+      <a:hlink>
+        <a:srgbClr val="467886"/>
+      </a:hlink>
+      <a:folHlink>
+        <a:srgbClr val="96607D"/>
+      </a:folHlink>
+    </a:clrScheme>
+    <a:fontScheme name="Office">
+      <a:majorFont>
+        <a:latin typeface="Aptos Display" panose="02110004020202020204"/>
+        <a:ea typeface=""/>
+        <a:cs typeface=""/>
+        <a:font script="Jpan" typeface="游ゴシック Light"/>
+        <a:font script="Hang" typeface="맑은 고딕"/>
+        <a:font script="Hans" typeface="等线 Light"/>
+        <a:font script="Hant" typeface="新細明體"/>
+        <a:font script="Arab" typeface="Times New Roman"/>
+        <a:font script="Hebr" typeface="Times New Roman"/>
+        <a:font script="Thai" typeface="Angsana New"/>
+        <a:font script="Ethi" typeface="Nyala"/>
+        <a:font script="Beng" typeface="Vrinda"/>
+        <a:font script="Gujr" typeface="Shruti"/>
+        <a:font script="Khmr" typeface="MoolBoran"/>
+        <a:font script="Knda" typeface="Tunga"/>
+        <a:font script="Guru" typeface="Raavi"/>
+        <a:font script="Cans" typeface="Euphemia"/>
+        <a:font script="Cher" typeface="Plantagenet Cherokee"/>
+        <a:font script="Yiii" typeface="Microsoft Yi Baiti"/>
+        <a:font script="Tibt" typeface="Microsoft Himalaya"/>
+        <a:font script="Thaa" typeface="MV Boli"/>
+        <a:font script="Deva" typeface="Mangal"/>
+        <a:font script="Telu" typeface="Gautami"/>
+        <a:font script="Taml" typeface="Latha"/>
+        <a:font script="Syrc" typeface="Estrangelo Edessa"/>
+        <a:font script="Orya" typeface="Kalinga"/>
+        <a:font script="Mlym" typeface="Kartika"/>
+        <a:font script="Laoo" typeface="DokChampa"/>
+        <a:font script="Sinh" typeface="Iskoola Pota"/>
+        <a:font script="Mong" typeface="Mongolian Baiti"/>
+        <a:font script="Viet" typeface="Times New Roman"/>
+        <a:font script="Uigh" typeface="Microsoft Uighur"/>
+        <a:font script="Geor" typeface="Sylfaen"/>
+        <a:font script="Armn" typeface="Arial"/>
+        <a:font script="Bugi" typeface="Leelawadee UI"/>
+        <a:font script="Bopo" typeface="Microsoft JhengHei"/>
+        <a:font script="Java" typeface="Javanese Text"/>
+        <a:font script="Lisu" typeface="Segoe UI"/>
+        <a:font script="Mymr" typeface="Myanmar Text"/>
+        <a:font script="Nkoo" typeface="Ebrima"/>
+        <a:font script="Olck" typeface="Nirmala UI"/>
+        <a:font script="Osma" typeface="Ebrima"/>
+        <a:font script="Phag" typeface="Phagspa"/>
+        <a:font script="Syrn" typeface="Estrangelo Edessa"/>
+        <a:font script="Syrj" typeface="Estrangelo Edessa"/>
+        <a:font script="Syre" typeface="Estrangelo Edessa"/>
+        <a:font script="Sora" typeface="Nirmala UI"/>
+        <a:font script="Tale" typeface="Microsoft Tai Le"/>
+        <a:font script="Talu" typeface="Microsoft New Tai Lue"/>
+        <a:font script="Tfng" typeface="Ebrima"/>
+      </a:majorFont>
+      <a:minorFont>
+        <a:latin typeface="Aptos" panose="02110004020202020204"/>
+        <a:ea typeface=""/>
+        <a:cs typeface=""/>
+        <a:font script="Jpan" typeface="游ゴシック"/>
+        <a:font script="Hang" typeface="맑은 고딕"/>
+        <a:font script="Hans" typeface="等线"/>
+        <a:font script="Hant" typeface="新細明體"/>
+        <a:font script="Arab" typeface="Arial"/>
+        <a:font script="Hebr" typeface="Arial"/>
+        <a:font script="Thai" typeface="Cordia New"/>
+        <a:font script="Ethi" typeface="Nyala"/>
+        <a:font script="Beng" typeface="Vrinda"/>
+        <a:font script="Gujr" typeface="Shruti"/>
+        <a:font script="Khmr" typeface="DaunPenh"/>
+        <a:font script="Knda" typeface="Tunga"/>
+        <a:font script="Guru" typeface="Raavi"/>
+        <a:font script="Cans" typeface="Euphemia"/>
+        <a:font script="Cher" typeface="Plantagenet Cherokee"/>
+        <a:font script="Yiii" typeface="Microsoft Yi Baiti"/>
+        <a:font script="Tibt" typeface="Microsoft Himalaya"/>
+        <a:font script="Thaa" typeface="MV Boli"/>
+        <a:font script="Deva" typeface="Mangal"/>
+        <a:font script="Telu" typeface="Gautami"/>
+        <a:font script="Taml" typeface="Latha"/>
+        <a:font script="Syrc" typeface="Estrangelo Edessa"/>
+        <a:font script="Orya" typeface="Kalinga"/>
+        <a:font script="Mlym" typeface="Kartika"/>
+        <a:font script="Laoo" typeface="DokChampa"/>
+        <a:font script="Sinh" typeface="Iskoola Pota"/>
+        <a:font script="Mong" typeface="Mongolian Baiti"/>
+        <a:font script="Viet" typeface="Arial"/>
+        <a:font script="Uigh" typeface="Microsoft Uighur"/>
+        <a:font script="Geor" typeface="Sylfaen"/>
+        <a:font script="Armn" typeface="Arial"/>
+        <a:font script="Bugi" typeface="Leelawadee UI"/>
+        <a:font script="Bopo" typeface="Microsoft JhengHei"/>
+        <a:font script="Java" typeface="Javanese Text"/>
+        <a:font script="Lisu" typeface="Segoe UI"/>
+        <a:font script="Mymr" typeface="Myanmar Text"/>
+        <a:font script="Nkoo" typeface="Ebrima"/>
+        <a:font script="Olck" typeface="Nirmala UI"/>
+        <a:font script="Osma" typeface="Ebrima"/>
+        <a:font script="Phag" typeface="Phagspa"/>
+        <a:font script="Syrn" typeface="Estrangelo Edessa"/>
+        <a:font script="Syrj" typeface="Estrangelo Edessa"/>
+        <a:font script="Syre" typeface="Estrangelo Edessa"/>
+        <a:font script="Sora" typeface="Nirmala UI"/>
+        <a:font script="Tale" typeface="Microsoft Tai Le"/>
+        <a:font script="Talu" typeface="Microsoft New Tai Lue"/>
+        <a:font script="Tfng" typeface="Ebrima"/>
+      </a:minorFont>
+    </a:fontScheme>
+    <a:fmtScheme name="Office">
+      <a:fillStyleLst>
+        <a:solidFill>
+          <a:schemeClr val="phClr"/>
+        </a:solidFill>
+        <a:gradFill rotWithShape="1">
+          <a:gsLst>
+            <a:gs pos="0">
+              <a:schemeClr val="phClr">
+                <a:lumMod val="110000"/>
+                <a:satMod val="105000"/>
+                <a:tint val="67000"/>
+              </a:schemeClr>
+            </a:gs>
+            <a:gs pos="50000">
+              <a:schemeClr val="phClr">
+                <a:lumMod val="105000"/>
+                <a:satMod val="103000"/>
+                <a:tint val="73000"/>
+              </a:schemeClr>
+            </a:gs>
+            <a:gs pos="100000">
+              <a:schemeClr val="phClr">
+                <a:lumMod val="105000"/>
+                <a:satMod val="109000"/>
+                <a:tint val="81000"/>
+              </a:schemeClr>
+            </a:gs>
+          </a:gsLst>
+          <a:lin ang="5400000" scaled="0"/>
+        </a:gradFill>
+        <a:gradFill rotWithShape="1">
+          <a:gsLst>
+            <a:gs pos="0">
+              <a:schemeClr val="phClr">
+                <a:satMod val="103000"/>
+                <a:lumMod val="102000"/>
+                <a:tint val="94000"/>
+              </a:schemeClr>
+            </a:gs>
+            <a:gs pos="50000">
+              <a:schemeClr val="phClr">
+                <a:satMod val="110000"/>
+                <a:lumMod val="100000"/>
+                <a:shade val="100000"/>
+              </a:schemeClr>
+            </a:gs>
+            <a:gs pos="100000">
+              <a:schemeClr val="phClr">
+                <a:lumMod val="99000"/>
+                <a:satMod val="120000"/>
+                <a:shade val="78000"/>
+              </a:schemeClr>
+            </a:gs>
+          </a:gsLst>
+          <a:lin ang="5400000" scaled="0"/>
+        </a:gradFill>
+      </a:fillStyleLst>
+      <a:lnStyleLst>
+        <a:ln w="12700" cap="flat" cmpd="sng" algn="ctr">
+          <a:solidFill>
+            <a:schemeClr val="phClr"/>
+          </a:solidFill>
+          <a:prstDash val="solid"/>
+          <a:miter lim="800000"/>
+        </a:ln>
+        <a:ln w="19050" cap="flat" cmpd="sng" algn="ctr">
+          <a:solidFill>
+            <a:schemeClr val="phClr"/>
+          </a:solidFill>
+          <a:prstDash val="solid"/>
+          <a:miter lim="800000"/>
+        </a:ln>
+        <a:ln w="25400" cap="flat" cmpd="sng" algn="ctr">
+          <a:solidFill>
+            <a:schemeClr val="phClr"/>
+          </a:solidFill>
+          <a:prstDash val="solid"/>
+          <a:miter lim="800000"/>
+        </a:ln>
+      </a:lnStyleLst>
+      <a:effectStyleLst>
+        <a:effectStyle>
+          <a:effectLst/>
+        </a:effectStyle>
+        <a:effectStyle>
+          <a:effectLst/>
+        </a:effectStyle>
+        <a:effectStyle>
+          <a:effectLst>
+            <a:outerShdw blurRad="57150" dist="19050" dir="5400000" algn="ctr" rotWithShape="0">
+              <a:srgbClr val="000000">
+                <a:alpha val="63000"/>
+              </a:srgbClr>
+            </a:outerShdw>
+          </a:effectLst>
+        </a:effectStyle>
+      </a:effectStyleLst>
+      <a:bgFillStyleLst>
+        <a:solidFill>
+          <a:schemeClr val="phClr"/>
+        </a:solidFill>
+        <a:solidFill>
+          <a:schemeClr val="phClr">
+            <a:tint val="95000"/>
+            <a:satMod val="170000"/>
+          </a:schemeClr>
+        </a:solidFill>
+        <a:gradFill rotWithShape="1">
+          <a:gsLst>
+            <a:gs pos="0">
+              <a:schemeClr val="phClr">
+                <a:tint val="93000"/>
+                <a:satMod val="150000"/>
+                <a:shade val="98000"/>
+                <a:lumMod val="102000"/>
+              </a:schemeClr>
+            </a:gs>
+            <a:gs pos="50000">
+              <a:schemeClr val="phClr">
+                <a:tint val="98000"/>
+                <a:satMod val="130000"/>
+                <a:shade val="90000"/>
+                <a:lumMod val="103000"/>
+              </a:schemeClr>
+            </a:gs>
+            <a:gs pos="100000">
+              <a:schemeClr val="phClr">
+                <a:shade val="63000"/>
+                <a:satMod val="120000"/>
+              </a:schemeClr>
+            </a:gs>
+          </a:gsLst>
+          <a:lin ang="5400000" scaled="0"/>
+        </a:gradFill>
+      </a:bgFillStyleLst>
+    </a:fmtScheme>
+  </a:themeElements>
+  <a:objectDefaults>
+    <a:lnDef>
+      <a:spPr/>
+      <a:bodyPr/>
+      <a:lstStyle/>
+      <a:style>
+        <a:lnRef idx="2">
+          <a:schemeClr val="accent1"/>
+        </a:lnRef>
+        <a:fillRef idx="0">
+          <a:schemeClr val="accent1"/>
+        </a:fillRef>
+        <a:effectRef idx="1">
+          <a:schemeClr val="accent1"/>
+        </a:effectRef>
+        <a:fontRef idx="minor">
+          <a:schemeClr val="tx1"/>
+        </a:fontRef>
+      </a:style>
+    </a:lnDef>
+  </a:objectDefaults>
+  <a:extraClrSchemeLst/>
+  <a:extLst>
+    <a:ext uri="{05A4C25C-085E-4340-85A3-A5531E510DB2}">
+      <thm15:themeFamily xmlns:thm15="http://schemas.microsoft.com/office/thememl/2012/main" name="Office Theme" id="{2E142A2C-CD16-42D6-873A-C26D2A0506FA}" vid="{1BDDFF52-6CD6-40A5-AB3C-68EB2F1E4D0A}"/>
+    </a:ext>
+  </a:extLst>
+</a:theme>
+</file>
+
+<file path=docMetadata/LabelInfo.xml><?xml version="1.0" encoding="utf-8"?>
+<clbl:labelList xmlns:clbl="http://schemas.microsoft.com/office/2020/mipLabelMetadata">
+  <clbl:label id="{f42aa342-8706-4288-bd11-ebb85995028c}" enabled="1" method="Privileged" siteId="{72f988bf-86f1-41af-91ab-2d7cd011db47}" removed="0"/>
+</clbl:labelList>
 </file>
</xml_diff>

<commit_message>
Update deck with footer (docs/ClosureCopilot.pptx); mp4 already footer version
Co-authored-by: Copilot <223556219+Copilot@users.noreply.github.com>
</commit_message>
<xml_diff>
--- a/docs/ClosureCopilot.pptx
+++ b/docs/ClosureCopilot.pptx
@@ -146,18 +146,18 @@
   <pc:docChgLst>
     <pc:chgData name="Mayuresh Piske" userId="aeb3d3e9-2c13-446e-8fc0-83f22db42824" providerId="ADAL" clId="{76688486-0801-4EB8-8479-3CA377FA07D4}"/>
     <pc:docChg chg="undo custSel modSld">
-      <pc:chgData name="Mayuresh Piske" userId="aeb3d3e9-2c13-446e-8fc0-83f22db42824" providerId="ADAL" clId="{76688486-0801-4EB8-8479-3CA377FA07D4}" dt="2026-09-05T15:36:38.970" v="104" actId="20577"/>
+      <pc:chgData name="Mayuresh Piske" userId="aeb3d3e9-2c13-446e-8fc0-83f22db42824" providerId="ADAL" clId="{76688486-0801-4EB8-8479-3CA377FA07D4}" dt="2026-09-05T15:46:48.348" v="107" actId="1076"/>
       <pc:docMkLst>
         <pc:docMk/>
       </pc:docMkLst>
       <pc:sldChg chg="addSp delSp modSp mod">
-        <pc:chgData name="Mayuresh Piske" userId="aeb3d3e9-2c13-446e-8fc0-83f22db42824" providerId="ADAL" clId="{76688486-0801-4EB8-8479-3CA377FA07D4}" dt="2026-09-05T15:35:46.493" v="95" actId="478"/>
+        <pc:chgData name="Mayuresh Piske" userId="aeb3d3e9-2c13-446e-8fc0-83f22db42824" providerId="ADAL" clId="{76688486-0801-4EB8-8479-3CA377FA07D4}" dt="2026-09-05T15:46:48.348" v="107" actId="1076"/>
         <pc:sldMkLst>
           <pc:docMk/>
           <pc:sldMk cId="0" sldId="256"/>
         </pc:sldMkLst>
         <pc:spChg chg="mod">
-          <ac:chgData name="Mayuresh Piske" userId="aeb3d3e9-2c13-446e-8fc0-83f22db42824" providerId="ADAL" clId="{76688486-0801-4EB8-8479-3CA377FA07D4}" dt="2026-09-05T15:26:34.418" v="39" actId="1076"/>
+          <ac:chgData name="Mayuresh Piske" userId="aeb3d3e9-2c13-446e-8fc0-83f22db42824" providerId="ADAL" clId="{76688486-0801-4EB8-8479-3CA377FA07D4}" dt="2026-09-05T15:46:43.561" v="106" actId="1076"/>
           <ac:spMkLst>
             <pc:docMk/>
             <pc:sldMk cId="0" sldId="256"/>
@@ -181,7 +181,7 @@
           </ac:spMkLst>
         </pc:spChg>
         <pc:spChg chg="add mod">
-          <ac:chgData name="Mayuresh Piske" userId="aeb3d3e9-2c13-446e-8fc0-83f22db42824" providerId="ADAL" clId="{76688486-0801-4EB8-8479-3CA377FA07D4}" dt="2026-09-05T15:19:43.651" v="25" actId="404"/>
+          <ac:chgData name="Mayuresh Piske" userId="aeb3d3e9-2c13-446e-8fc0-83f22db42824" providerId="ADAL" clId="{76688486-0801-4EB8-8479-3CA377FA07D4}" dt="2026-09-05T15:46:48.348" v="107" actId="1076"/>
           <ac:spMkLst>
             <pc:docMk/>
             <pc:sldMk cId="0" sldId="256"/>
@@ -3955,7 +3955,7 @@
         </p:nvSpPr>
         <p:spPr>
           <a:xfrm>
-            <a:off x="868680" y="5501640"/>
+            <a:off x="868680" y="5921262"/>
             <a:ext cx="10515600" cy="400110"/>
           </a:xfrm>
           <a:prstGeom prst="rect">

</xml_diff>